<commit_message>
Docs and deck complete: evaluation mapping, business, risks, exact sources, screenshots
- Deck: real app screenshots (title, solution flow), full roadmap, current numbers,
  layout fixed after rendering every slide
- docs/EVALUATION.md, docs/BUSINESS.md (GTM + impact metrics), docs/RISKS.md
- DATA_SOURCES with the exact links embedded in the playbook
- README, checklist and demo script updated for the finished build

Co-Authored-By: Claude Opus 5.5 <noreply@anthropic.com>
Claude-Session: https://claude.ai/code/session_01V6KbV22c793AuoVwTAPzcw
</commit_message>
<xml_diff>
--- a/docs/DawaCheck_pitch.pptx
+++ b/docs/DawaCheck_pitch.pptx
@@ -1832,412 +1832,30 @@
           </a:p>
         </p:txBody>
       </p:sp>
-      <p:sp>
-        <p:nvSpPr>
-          <p:cNvPr id="6" name="Shape 4"/>
-          <p:cNvSpPr/>
-          <p:nvPr/>
-        </p:nvSpPr>
-        <p:spPr>
-          <a:xfrm>
-            <a:off x="6400800" y="548640"/>
-            <a:ext cx="2103120" cy="4023360"/>
-          </a:xfrm>
-          <a:prstGeom prst="roundRect">
-            <a:avLst>
-              <a:gd name="adj" fmla="val 13043"/>
-            </a:avLst>
-          </a:prstGeom>
-          <a:solidFill>
-            <a:srgbClr val="0F1A12"/>
-          </a:solidFill>
-          <a:ln w="12700">
-            <a:solidFill>
-              <a:srgbClr val="0F1A12"/>
-            </a:solidFill>
-            <a:prstDash val="solid"/>
-          </a:ln>
-        </p:spPr>
-      </p:sp>
-      <p:sp>
-        <p:nvSpPr>
-          <p:cNvPr id="7" name="Shape 5"/>
-          <p:cNvSpPr/>
-          <p:nvPr/>
-        </p:nvSpPr>
-        <p:spPr>
-          <a:xfrm>
-            <a:off x="6510528" y="713232"/>
-            <a:ext cx="1883664" cy="3694176"/>
-          </a:xfrm>
-          <a:prstGeom prst="roundRect">
-            <a:avLst>
-              <a:gd name="adj" fmla="val 9709"/>
-            </a:avLst>
-          </a:prstGeom>
-          <a:solidFill>
-            <a:srgbClr val="FFFFFF"/>
-          </a:solidFill>
-          <a:ln w="12700">
-            <a:solidFill>
-              <a:srgbClr val="FFFFFF"/>
-            </a:solidFill>
-            <a:prstDash val="solid"/>
-          </a:ln>
-        </p:spPr>
-      </p:sp>
-      <p:sp>
-        <p:nvSpPr>
-          <p:cNvPr id="8" name="Shape 6"/>
-          <p:cNvSpPr/>
-          <p:nvPr/>
-        </p:nvSpPr>
-        <p:spPr>
-          <a:xfrm>
-            <a:off x="6629400" y="960120"/>
-            <a:ext cx="1645920" cy="1463040"/>
-          </a:xfrm>
-          <a:prstGeom prst="roundRect">
-            <a:avLst>
-              <a:gd name="adj" fmla="val 9375"/>
-            </a:avLst>
-          </a:prstGeom>
-          <a:solidFill>
-            <a:srgbClr val="E3F3E7"/>
-          </a:solidFill>
-          <a:ln w="12700">
-            <a:solidFill>
-              <a:srgbClr val="E3F3E7"/>
-            </a:solidFill>
-            <a:prstDash val="solid"/>
-          </a:ln>
-        </p:spPr>
-      </p:sp>
-      <p:sp>
-        <p:nvSpPr>
-          <p:cNvPr id="9" name="Shape 7"/>
-          <p:cNvSpPr/>
-          <p:nvPr/>
-        </p:nvSpPr>
-        <p:spPr>
-          <a:xfrm>
-            <a:off x="7196328" y="1097280"/>
-            <a:ext cx="512064" cy="512064"/>
-          </a:xfrm>
-          <a:prstGeom prst="ellipse">
-            <a:avLst/>
-          </a:prstGeom>
-          <a:solidFill>
-            <a:srgbClr val="1F7A3A"/>
-          </a:solidFill>
-          <a:ln w="12700">
-            <a:solidFill>
-              <a:srgbClr val="1F7A3A"/>
-            </a:solidFill>
-            <a:prstDash val="solid"/>
-          </a:ln>
-        </p:spPr>
-      </p:sp>
-      <p:sp>
-        <p:nvSpPr>
-          <p:cNvPr id="10" name="Text 8"/>
-          <p:cNvSpPr txBox="1"/>
-          <p:nvPr/>
-        </p:nvSpPr>
-        <p:spPr>
-          <a:xfrm>
-            <a:off x="7196328" y="1097280"/>
-            <a:ext cx="512064" cy="512064"/>
-          </a:xfrm>
-          <a:prstGeom prst="rect">
-            <a:avLst/>
-          </a:prstGeom>
-          <a:noFill/>
-          <a:ln/>
-        </p:spPr>
-        <p:txBody>
-          <a:bodyPr wrap="square" lIns="0" tIns="0" rIns="0" bIns="0" rtlCol="0" anchor="ctr"/>
-          <a:lstStyle/>
-          <a:p>
-            <a:pPr algn="ctr" indent="0" marL="0">
-              <a:buNone/>
-            </a:pPr>
-            <a:r>
-              <a:rPr lang="en-US" sz="2200" b="1" dirty="0">
-                <a:solidFill>
-                  <a:srgbClr val="FFFFFF"/>
-                </a:solidFill>
-                <a:latin typeface="Calibri" pitchFamily="34" charset="0"/>
-                <a:ea typeface="Calibri" pitchFamily="34" charset="-122"/>
-                <a:cs typeface="Calibri" pitchFamily="34" charset="-120"/>
-              </a:rPr>
-              <a:t>✓</a:t>
-            </a:r>
-            <a:endParaRPr lang="en-US" sz="2200" dirty="0"/>
-          </a:p>
-        </p:txBody>
-      </p:sp>
-      <p:sp>
-        <p:nvSpPr>
-          <p:cNvPr id="11" name="Text 9"/>
-          <p:cNvSpPr txBox="1"/>
-          <p:nvPr/>
-        </p:nvSpPr>
-        <p:spPr>
-          <a:xfrm>
-            <a:off x="6675120" y="1691640"/>
-            <a:ext cx="1554480" cy="640080"/>
-          </a:xfrm>
-          <a:prstGeom prst="rect">
-            <a:avLst/>
-          </a:prstGeom>
-          <a:noFill/>
-          <a:ln/>
-        </p:spPr>
-        <p:txBody>
-          <a:bodyPr wrap="square" lIns="0" tIns="0" rIns="0" bIns="0" rtlCol="0" anchor="ctr"/>
-          <a:lstStyle/>
-          <a:p>
-            <a:pPr algn="ctr" indent="0" marL="0">
-              <a:buNone/>
-            </a:pPr>
-            <a:r>
-              <a:rPr lang="en-US" sz="1100" b="1" dirty="0">
-                <a:solidFill>
-                  <a:srgbClr val="1F7A3A"/>
-                </a:solidFill>
-                <a:latin typeface="Calibri" pitchFamily="34" charset="0"/>
-                <a:ea typeface="Calibri" pitchFamily="34" charset="-122"/>
-                <a:cs typeface="Calibri" pitchFamily="34" charset="-120"/>
-              </a:rPr>
-              <a:t>Safe to use as per label</a:t>
-            </a:r>
-            <a:endParaRPr lang="en-US" sz="1100" dirty="0"/>
-          </a:p>
-        </p:txBody>
-      </p:sp>
-      <p:sp>
-        <p:nvSpPr>
-          <p:cNvPr id="12" name="Text 10"/>
-          <p:cNvSpPr txBox="1"/>
-          <p:nvPr/>
-        </p:nvSpPr>
-        <p:spPr>
-          <a:xfrm>
-            <a:off x="6675120" y="2560320"/>
-            <a:ext cx="1554480" cy="274320"/>
-          </a:xfrm>
-          <a:prstGeom prst="rect">
-            <a:avLst/>
-          </a:prstGeom>
-          <a:noFill/>
-          <a:ln/>
-        </p:spPr>
-        <p:txBody>
-          <a:bodyPr wrap="square" lIns="0" tIns="0" rIns="0" bIns="0" rtlCol="0" anchor="ctr"/>
-          <a:lstStyle/>
-          <a:p>
-            <a:pPr indent="0" marL="0">
-              <a:buNone/>
-            </a:pPr>
-            <a:r>
-              <a:rPr lang="en-US" sz="950" b="1" dirty="0">
-                <a:solidFill>
-                  <a:srgbClr val="1D231F"/>
-                </a:solidFill>
-                <a:latin typeface="Calibri" pitchFamily="34" charset="0"/>
-                <a:ea typeface="Calibri" pitchFamily="34" charset="-122"/>
-                <a:cs typeface="Calibri" pitchFamily="34" charset="-120"/>
-              </a:rPr>
-              <a:t>30 ml per 15 L tank</a:t>
-            </a:r>
-            <a:endParaRPr lang="en-US" sz="950" dirty="0"/>
-          </a:p>
-        </p:txBody>
-      </p:sp>
-      <p:sp>
-        <p:nvSpPr>
-          <p:cNvPr id="13" name="Text 11"/>
-          <p:cNvSpPr txBox="1"/>
-          <p:nvPr/>
-        </p:nvSpPr>
-        <p:spPr>
-          <a:xfrm>
-            <a:off x="6675120" y="2889504"/>
-            <a:ext cx="1554480" cy="274320"/>
-          </a:xfrm>
-          <a:prstGeom prst="rect">
-            <a:avLst/>
-          </a:prstGeom>
-          <a:noFill/>
-          <a:ln/>
-        </p:spPr>
-        <p:txBody>
-          <a:bodyPr wrap="square" lIns="0" tIns="0" rIns="0" bIns="0" rtlCol="0" anchor="ctr"/>
-          <a:lstStyle/>
-          <a:p>
-            <a:pPr indent="0" marL="0">
-              <a:buNone/>
-            </a:pPr>
-            <a:r>
-              <a:rPr lang="en-US" sz="950" dirty="0">
-                <a:solidFill>
-                  <a:srgbClr val="1D231F"/>
-                </a:solidFill>
-                <a:latin typeface="Calibri" pitchFamily="34" charset="0"/>
-                <a:ea typeface="Calibri" pitchFamily="34" charset="-122"/>
-                <a:cs typeface="Calibri" pitchFamily="34" charset="-120"/>
-              </a:rPr>
-              <a:t>8 tanks for your 1 acre</a:t>
-            </a:r>
-            <a:endParaRPr lang="en-US" sz="950" dirty="0"/>
-          </a:p>
-        </p:txBody>
-      </p:sp>
-      <p:sp>
-        <p:nvSpPr>
-          <p:cNvPr id="14" name="Text 12"/>
-          <p:cNvSpPr txBox="1"/>
-          <p:nvPr/>
-        </p:nvSpPr>
-        <p:spPr>
-          <a:xfrm>
-            <a:off x="6675120" y="3218688"/>
-            <a:ext cx="1554480" cy="274320"/>
-          </a:xfrm>
-          <a:prstGeom prst="rect">
-            <a:avLst/>
-          </a:prstGeom>
-          <a:noFill/>
-          <a:ln/>
-        </p:spPr>
-        <p:txBody>
-          <a:bodyPr wrap="square" lIns="0" tIns="0" rIns="0" bIns="0" rtlCol="0" anchor="ctr"/>
-          <a:lstStyle/>
-          <a:p>
-            <a:pPr indent="0" marL="0">
-              <a:buNone/>
-            </a:pPr>
-            <a:r>
-              <a:rPr lang="en-US" sz="950" dirty="0">
-                <a:solidFill>
-                  <a:srgbClr val="1D231F"/>
-                </a:solidFill>
-                <a:latin typeface="Calibri" pitchFamily="34" charset="0"/>
-                <a:ea typeface="Calibri" pitchFamily="34" charset="-122"/>
-                <a:cs typeface="Calibri" pitchFamily="34" charset="-120"/>
-              </a:rPr>
-              <a:t>Do not harvest before 14 Oct</a:t>
-            </a:r>
-            <a:endParaRPr lang="en-US" sz="950" dirty="0"/>
-          </a:p>
-        </p:txBody>
-      </p:sp>
-      <p:sp>
-        <p:nvSpPr>
-          <p:cNvPr id="15" name="Text 13"/>
-          <p:cNvSpPr txBox="1"/>
-          <p:nvPr/>
-        </p:nvSpPr>
-        <p:spPr>
-          <a:xfrm>
-            <a:off x="6675120" y="3547872"/>
-            <a:ext cx="1554480" cy="274320"/>
-          </a:xfrm>
-          <a:prstGeom prst="rect">
-            <a:avLst/>
-          </a:prstGeom>
-          <a:noFill/>
-          <a:ln/>
-        </p:spPr>
-        <p:txBody>
-          <a:bodyPr wrap="square" lIns="0" tIns="0" rIns="0" bIns="0" rtlCol="0" anchor="ctr"/>
-          <a:lstStyle/>
-          <a:p>
-            <a:pPr indent="0" marL="0">
-              <a:buNone/>
-            </a:pPr>
-            <a:r>
-              <a:rPr lang="en-US" sz="950" dirty="0">
-                <a:solidFill>
-                  <a:srgbClr val="1D231F"/>
-                </a:solidFill>
-                <a:latin typeface="Calibri" pitchFamily="34" charset="0"/>
-                <a:ea typeface="Calibri" pitchFamily="34" charset="-122"/>
-                <a:cs typeface="Calibri" pitchFamily="34" charset="-120"/>
-              </a:rPr>
-              <a:t>Wear gloves and mask</a:t>
-            </a:r>
-            <a:endParaRPr lang="en-US" sz="950" dirty="0"/>
-          </a:p>
-        </p:txBody>
-      </p:sp>
-      <p:sp>
-        <p:nvSpPr>
-          <p:cNvPr id="16" name="Shape 14"/>
-          <p:cNvSpPr/>
-          <p:nvPr/>
-        </p:nvSpPr>
-        <p:spPr>
-          <a:xfrm>
-            <a:off x="6675120" y="3886200"/>
-            <a:ext cx="1554480" cy="347472"/>
-          </a:xfrm>
-          <a:prstGeom prst="roundRect">
-            <a:avLst>
-              <a:gd name="adj" fmla="val 21053"/>
-            </a:avLst>
-          </a:prstGeom>
-          <a:solidFill>
-            <a:srgbClr val="1F7A3A"/>
-          </a:solidFill>
-          <a:ln w="12700">
-            <a:solidFill>
-              <a:srgbClr val="1F7A3A"/>
-            </a:solidFill>
-            <a:prstDash val="solid"/>
-          </a:ln>
-        </p:spPr>
-      </p:sp>
-      <p:sp>
-        <p:nvSpPr>
-          <p:cNvPr id="17" name="Text 15"/>
-          <p:cNvSpPr txBox="1"/>
-          <p:nvPr/>
-        </p:nvSpPr>
-        <p:spPr>
-          <a:xfrm>
-            <a:off x="6675120" y="3886200"/>
-            <a:ext cx="1554480" cy="347472"/>
-          </a:xfrm>
-          <a:prstGeom prst="rect">
-            <a:avLst/>
-          </a:prstGeom>
-          <a:noFill/>
-          <a:ln/>
-        </p:spPr>
-        <p:txBody>
-          <a:bodyPr wrap="square" lIns="0" tIns="0" rIns="0" bIns="0" rtlCol="0" anchor="ctr"/>
-          <a:lstStyle/>
-          <a:p>
-            <a:pPr algn="ctr" indent="0" marL="0">
-              <a:buNone/>
-            </a:pPr>
-            <a:r>
-              <a:rPr lang="en-US" sz="1000" b="1" dirty="0">
-                <a:solidFill>
-                  <a:srgbClr val="FFFFFF"/>
-                </a:solidFill>
-                <a:latin typeface="Calibri" pitchFamily="34" charset="0"/>
-                <a:ea typeface="Calibri" pitchFamily="34" charset="-122"/>
-                <a:cs typeface="Calibri" pitchFamily="34" charset="-120"/>
-              </a:rPr>
-              <a:t>Save spray</a:t>
-            </a:r>
-            <a:endParaRPr lang="en-US" sz="1000" dirty="0"/>
-          </a:p>
-        </p:txBody>
-      </p:sp>
+      <p:pic>
+        <p:nvPicPr>
+          <p:cNvPr id="6" name="Image 0" descr="DawaCheck app showing a green verdict">    </p:cNvPr>
+          <p:cNvPicPr>
+            <a:picLocks noChangeAspect="1"/>
+          </p:cNvPicPr>
+          <p:nvPr/>
+        </p:nvPicPr>
+        <p:blipFill>
+          <a:blip r:embed="rId1"/>
+          <a:stretch>
+            <a:fillRect/>
+          </a:stretch>
+        </p:blipFill>
+        <p:spPr>
+          <a:xfrm>
+            <a:off x="6492240" y="411480"/>
+            <a:ext cx="2148840" cy="4297680"/>
+          </a:xfrm>
+          <a:prstGeom prst="rect">
+            <a:avLst/>
+          </a:prstGeom>
+        </p:spPr>
+      </p:pic>
     </p:spTree>
   </p:cSld>
   <p:clrMapOvr>
@@ -2317,8 +1935,8 @@
         </p:nvSpPr>
         <p:spPr>
           <a:xfrm>
-            <a:off x="457200" y="1143000"/>
-            <a:ext cx="822960" cy="457200"/>
+            <a:off x="457200" y="960120"/>
+            <a:ext cx="1965960" cy="301752"/>
           </a:xfrm>
           <a:prstGeom prst="rect">
             <a:avLst/>
@@ -2336,13 +1954,13 @@
             <a:r>
               <a:rPr lang="en-US" sz="1200" b="1" dirty="0">
                 <a:solidFill>
-                  <a:srgbClr val="B7D3BF"/>
+                  <a:srgbClr val="FFFFFF"/>
                 </a:solidFill>
                 <a:latin typeface="Calibri" pitchFamily="34" charset="0"/>
                 <a:ea typeface="Calibri" pitchFamily="34" charset="-122"/>
                 <a:cs typeface="Calibri" pitchFamily="34" charset="-120"/>
               </a:rPr>
-              <a:t>Next</a:t>
+              <a:t>Packaging forensics</a:t>
             </a:r>
             <a:endParaRPr lang="en-US" sz="1200" dirty="0"/>
           </a:p>
@@ -2356,8 +1974,8 @@
         </p:nvSpPr>
         <p:spPr>
           <a:xfrm>
-            <a:off x="1280160" y="1143000"/>
-            <a:ext cx="4023360" cy="457200"/>
+            <a:off x="2468880" y="960120"/>
+            <a:ext cx="3017520" cy="301752"/>
           </a:xfrm>
           <a:prstGeom prst="rect">
             <a:avLst/>
@@ -2373,17 +1991,17 @@
               <a:buNone/>
             </a:pPr>
             <a:r>
-              <a:rPr lang="en-US" sz="1400" dirty="0">
-                <a:solidFill>
-                  <a:srgbClr val="FFFFFF"/>
+              <a:rPr lang="en-US" sz="1050" dirty="0">
+                <a:solidFill>
+                  <a:srgbClr val="D5E8DA"/>
                 </a:solidFill>
                 <a:latin typeface="Calibri" pitchFamily="34" charset="0"/>
                 <a:ea typeface="Calibri" pitchFamily="34" charset="-122"/>
                 <a:cs typeface="Calibri" pitchFamily="34" charset="-120"/>
               </a:rPr>
-              <a:t>Packaging forensics (genuine vs suspicious pack photos)</a:t>
-            </a:r>
-            <a:endParaRPr lang="en-US" sz="1400" dirty="0"/>
+              <a:t>compare pack photos with genuine packs</a:t>
+            </a:r>
+            <a:endParaRPr lang="en-US" sz="1050" dirty="0"/>
           </a:p>
         </p:txBody>
       </p:sp>
@@ -2395,8 +2013,8 @@
         </p:nvSpPr>
         <p:spPr>
           <a:xfrm>
-            <a:off x="457200" y="1801368"/>
-            <a:ext cx="822960" cy="457200"/>
+            <a:off x="457200" y="1289304"/>
+            <a:ext cx="1965960" cy="301752"/>
           </a:xfrm>
           <a:prstGeom prst="rect">
             <a:avLst/>
@@ -2414,13 +2032,13 @@
             <a:r>
               <a:rPr lang="en-US" sz="1200" b="1" dirty="0">
                 <a:solidFill>
-                  <a:srgbClr val="B7D3BF"/>
+                  <a:srgbClr val="FFFFFF"/>
                 </a:solidFill>
                 <a:latin typeface="Calibri" pitchFamily="34" charset="0"/>
                 <a:ea typeface="Calibri" pitchFamily="34" charset="-122"/>
                 <a:cs typeface="Calibri" pitchFamily="34" charset="-120"/>
               </a:rPr>
-              <a:t>Next</a:t>
+              <a:t>IVR / missed call</a:t>
             </a:r>
             <a:endParaRPr lang="en-US" sz="1200" dirty="0"/>
           </a:p>
@@ -2434,8 +2052,8 @@
         </p:nvSpPr>
         <p:spPr>
           <a:xfrm>
-            <a:off x="1280160" y="1801368"/>
-            <a:ext cx="4023360" cy="457200"/>
+            <a:off x="2468880" y="1289304"/>
+            <a:ext cx="3017520" cy="301752"/>
           </a:xfrm>
           <a:prstGeom prst="rect">
             <a:avLst/>
@@ -2451,17 +2069,17 @@
               <a:buNone/>
             </a:pPr>
             <a:r>
-              <a:rPr lang="en-US" sz="1400" dirty="0">
-                <a:solidFill>
-                  <a:srgbClr val="FFFFFF"/>
+              <a:rPr lang="en-US" sz="1050" dirty="0">
+                <a:solidFill>
+                  <a:srgbClr val="D5E8DA"/>
                 </a:solidFill>
                 <a:latin typeface="Calibri" pitchFamily="34" charset="0"/>
                 <a:ea typeface="Calibri" pitchFamily="34" charset="-122"/>
                 <a:cs typeface="Calibri" pitchFamily="34" charset="-120"/>
               </a:rPr>
-              <a:t>IVR / missed-call access for feature phones</a:t>
-            </a:r>
-            <a:endParaRPr lang="en-US" sz="1400" dirty="0"/>
+              <a:t>for feature phones</a:t>
+            </a:r>
+            <a:endParaRPr lang="en-US" sz="1050" dirty="0"/>
           </a:p>
         </p:txBody>
       </p:sp>
@@ -2473,8 +2091,8 @@
         </p:nvSpPr>
         <p:spPr>
           <a:xfrm>
-            <a:off x="457200" y="2459736"/>
-            <a:ext cx="822960" cy="457200"/>
+            <a:off x="457200" y="1618488"/>
+            <a:ext cx="1965960" cy="301752"/>
           </a:xfrm>
           <a:prstGeom prst="rect">
             <a:avLst/>
@@ -2492,13 +2110,13 @@
             <a:r>
               <a:rPr lang="en-US" sz="1200" b="1" dirty="0">
                 <a:solidFill>
-                  <a:srgbClr val="B7D3BF"/>
+                  <a:srgbClr val="FFFFFF"/>
                 </a:solidFill>
                 <a:latin typeface="Calibri" pitchFamily="34" charset="0"/>
                 <a:ea typeface="Calibri" pitchFamily="34" charset="-122"/>
                 <a:cs typeface="Calibri" pitchFamily="34" charset="-120"/>
               </a:rPr>
-              <a:t>Later</a:t>
+              <a:t>WhatsApp bot</a:t>
             </a:r>
             <a:endParaRPr lang="en-US" sz="1200" dirty="0"/>
           </a:p>
@@ -2512,8 +2130,8 @@
         </p:nvSpPr>
         <p:spPr>
           <a:xfrm>
-            <a:off x="1280160" y="2459736"/>
-            <a:ext cx="4023360" cy="457200"/>
+            <a:off x="2468880" y="1618488"/>
+            <a:ext cx="3017520" cy="301752"/>
           </a:xfrm>
           <a:prstGeom prst="rect">
             <a:avLst/>
@@ -2529,17 +2147,17 @@
               <a:buNone/>
             </a:pPr>
             <a:r>
-              <a:rPr lang="en-US" sz="1400" dirty="0">
-                <a:solidFill>
-                  <a:srgbClr val="FFFFFF"/>
+              <a:rPr lang="en-US" sz="1050" dirty="0">
+                <a:solidFill>
+                  <a:srgbClr val="D5E8DA"/>
                 </a:solidFill>
                 <a:latin typeface="Calibri" pitchFamily="34" charset="0"/>
                 <a:ea typeface="Calibri" pitchFamily="34" charset="-122"/>
                 <a:cs typeface="Calibri" pitchFamily="34" charset="-120"/>
               </a:rPr>
-              <a:t>WhatsApp bot, diagnosis link, drone mode</a:t>
-            </a:r>
-            <a:endParaRPr lang="en-US" sz="1400" dirty="0"/>
+              <a:t>scan and verdict, no app install</a:t>
+            </a:r>
+            <a:endParaRPr lang="en-US" sz="1050" dirty="0"/>
           </a:p>
         </p:txBody>
       </p:sp>
@@ -2551,8 +2169,8 @@
         </p:nvSpPr>
         <p:spPr>
           <a:xfrm>
-            <a:off x="457200" y="3118104"/>
-            <a:ext cx="822960" cy="457200"/>
+            <a:off x="457200" y="1947672"/>
+            <a:ext cx="1965960" cy="301752"/>
           </a:xfrm>
           <a:prstGeom prst="rect">
             <a:avLst/>
@@ -2570,13 +2188,13 @@
             <a:r>
               <a:rPr lang="en-US" sz="1200" b="1" dirty="0">
                 <a:solidFill>
-                  <a:srgbClr val="B7D3BF"/>
+                  <a:srgbClr val="FFFFFF"/>
                 </a:solidFill>
                 <a:latin typeface="Calibri" pitchFamily="34" charset="0"/>
                 <a:ea typeface="Calibri" pitchFamily="34" charset="-122"/>
                 <a:cs typeface="Calibri" pitchFamily="34" charset="-120"/>
               </a:rPr>
-              <a:t>Later</a:t>
+              <a:t>Diagnosis link</a:t>
             </a:r>
             <a:endParaRPr lang="en-US" sz="1200" dirty="0"/>
           </a:p>
@@ -2590,8 +2208,8 @@
         </p:nvSpPr>
         <p:spPr>
           <a:xfrm>
-            <a:off x="1280160" y="3118104"/>
-            <a:ext cx="4023360" cy="457200"/>
+            <a:off x="2468880" y="1947672"/>
+            <a:ext cx="3017520" cy="301752"/>
           </a:xfrm>
           <a:prstGeom prst="rect">
             <a:avLst/>
@@ -2607,23 +2225,413 @@
               <a:buNone/>
             </a:pPr>
             <a:r>
-              <a:rPr lang="en-US" sz="1400" dirty="0">
-                <a:solidFill>
-                  <a:srgbClr val="FFFFFF"/>
+              <a:rPr lang="en-US" sz="1050" dirty="0">
+                <a:solidFill>
+                  <a:srgbClr val="D5E8DA"/>
                 </a:solidFill>
                 <a:latin typeface="Calibri" pitchFamily="34" charset="0"/>
                 <a:ea typeface="Calibri" pitchFamily="34" charset="-122"/>
                 <a:cs typeface="Calibri" pitchFamily="34" charset="-120"/>
               </a:rPr>
-              <a:t>AgriStack and Kisan Call Centre integration</a:t>
-            </a:r>
-            <a:endParaRPr lang="en-US" sz="1400" dirty="0"/>
-          </a:p>
-        </p:txBody>
-      </p:sp>
-      <p:sp>
-        <p:nvSpPr>
-          <p:cNvPr id="11" name="Shape 9"/>
+              <a:t>crop photo feeds the label-claim check</a:t>
+            </a:r>
+            <a:endParaRPr lang="en-US" sz="1050" dirty="0"/>
+          </a:p>
+        </p:txBody>
+      </p:sp>
+      <p:sp>
+        <p:nvSpPr>
+          <p:cNvPr id="11" name="Text 9"/>
+          <p:cNvSpPr txBox="1"/>
+          <p:nvPr/>
+        </p:nvSpPr>
+        <p:spPr>
+          <a:xfrm>
+            <a:off x="457200" y="2276856"/>
+            <a:ext cx="1965960" cy="301752"/>
+          </a:xfrm>
+          <a:prstGeom prst="rect">
+            <a:avLst/>
+          </a:prstGeom>
+          <a:noFill/>
+          <a:ln/>
+        </p:spPr>
+        <p:txBody>
+          <a:bodyPr wrap="square" lIns="0" tIns="0" rIns="0" bIns="0" rtlCol="0" anchor="ctr"/>
+          <a:lstStyle/>
+          <a:p>
+            <a:pPr indent="0" marL="0">
+              <a:buNone/>
+            </a:pPr>
+            <a:r>
+              <a:rPr lang="en-US" sz="1200" b="1" dirty="0">
+                <a:solidFill>
+                  <a:srgbClr val="FFFFFF"/>
+                </a:solidFill>
+                <a:latin typeface="Calibri" pitchFamily="34" charset="0"/>
+                <a:ea typeface="Calibri" pitchFamily="34" charset="-122"/>
+                <a:cs typeface="Calibri" pitchFamily="34" charset="-120"/>
+              </a:rPr>
+              <a:t>Dealer trust score</a:t>
+            </a:r>
+            <a:endParaRPr lang="en-US" sz="1200" dirty="0"/>
+          </a:p>
+        </p:txBody>
+      </p:sp>
+      <p:sp>
+        <p:nvSpPr>
+          <p:cNvPr id="12" name="Text 10"/>
+          <p:cNvSpPr txBox="1"/>
+          <p:nvPr/>
+        </p:nvSpPr>
+        <p:spPr>
+          <a:xfrm>
+            <a:off x="2468880" y="2276856"/>
+            <a:ext cx="3017520" cy="301752"/>
+          </a:xfrm>
+          <a:prstGeom prst="rect">
+            <a:avLst/>
+          </a:prstGeom>
+          <a:noFill/>
+          <a:ln/>
+        </p:spPr>
+        <p:txBody>
+          <a:bodyPr wrap="square" lIns="0" tIns="0" rIns="0" bIns="0" rtlCol="0" anchor="ctr"/>
+          <a:lstStyle/>
+          <a:p>
+            <a:pPr indent="0" marL="0">
+              <a:buNone/>
+            </a:pPr>
+            <a:r>
+              <a:rPr lang="en-US" sz="1050" dirty="0">
+                <a:solidFill>
+                  <a:srgbClr val="D5E8DA"/>
+                </a:solidFill>
+                <a:latin typeface="Calibri" pitchFamily="34" charset="0"/>
+                <a:ea typeface="Calibri" pitchFamily="34" charset="-122"/>
+                <a:cs typeface="Calibri" pitchFamily="34" charset="-120"/>
+              </a:rPr>
+              <a:t>Verified Dealer badge</a:t>
+            </a:r>
+            <a:endParaRPr lang="en-US" sz="1050" dirty="0"/>
+          </a:p>
+        </p:txBody>
+      </p:sp>
+      <p:sp>
+        <p:nvSpPr>
+          <p:cNvPr id="13" name="Text 11"/>
+          <p:cNvSpPr txBox="1"/>
+          <p:nvPr/>
+        </p:nvSpPr>
+        <p:spPr>
+          <a:xfrm>
+            <a:off x="457200" y="2606040"/>
+            <a:ext cx="1965960" cy="301752"/>
+          </a:xfrm>
+          <a:prstGeom prst="rect">
+            <a:avLst/>
+          </a:prstGeom>
+          <a:noFill/>
+          <a:ln/>
+        </p:spPr>
+        <p:txBody>
+          <a:bodyPr wrap="square" lIns="0" tIns="0" rIns="0" bIns="0" rtlCol="0" anchor="ctr"/>
+          <a:lstStyle/>
+          <a:p>
+            <a:pPr indent="0" marL="0">
+              <a:buNone/>
+            </a:pPr>
+            <a:r>
+              <a:rPr lang="en-US" sz="1200" b="1" dirty="0">
+                <a:solidFill>
+                  <a:srgbClr val="FFFFFF"/>
+                </a:solidFill>
+                <a:latin typeface="Calibri" pitchFamily="34" charset="0"/>
+                <a:ea typeface="Calibri" pitchFamily="34" charset="-122"/>
+                <a:cs typeface="Calibri" pitchFamily="34" charset="-120"/>
+              </a:rPr>
+              <a:t>Drone mode</a:t>
+            </a:r>
+            <a:endParaRPr lang="en-US" sz="1200" dirty="0"/>
+          </a:p>
+        </p:txBody>
+      </p:sp>
+      <p:sp>
+        <p:nvSpPr>
+          <p:cNvPr id="14" name="Text 12"/>
+          <p:cNvSpPr txBox="1"/>
+          <p:nvPr/>
+        </p:nvSpPr>
+        <p:spPr>
+          <a:xfrm>
+            <a:off x="2468880" y="2606040"/>
+            <a:ext cx="3017520" cy="301752"/>
+          </a:xfrm>
+          <a:prstGeom prst="rect">
+            <a:avLst/>
+          </a:prstGeom>
+          <a:noFill/>
+          <a:ln/>
+        </p:spPr>
+        <p:txBody>
+          <a:bodyPr wrap="square" lIns="0" tIns="0" rIns="0" bIns="0" rtlCol="0" anchor="ctr"/>
+          <a:lstStyle/>
+          <a:p>
+            <a:pPr indent="0" marL="0">
+              <a:buNone/>
+            </a:pPr>
+            <a:r>
+              <a:rPr lang="en-US" sz="1050" dirty="0">
+                <a:solidFill>
+                  <a:srgbClr val="D5E8DA"/>
+                </a:solidFill>
+                <a:latin typeface="Calibri" pitchFamily="34" charset="0"/>
+                <a:ea typeface="Calibri" pitchFamily="34" charset="-122"/>
+                <a:cs typeface="Calibri" pitchFamily="34" charset="-120"/>
+              </a:rPr>
+              <a:t>drone approval status + SOP</a:t>
+            </a:r>
+            <a:endParaRPr lang="en-US" sz="1050" dirty="0"/>
+          </a:p>
+        </p:txBody>
+      </p:sp>
+      <p:sp>
+        <p:nvSpPr>
+          <p:cNvPr id="15" name="Text 13"/>
+          <p:cNvSpPr txBox="1"/>
+          <p:nvPr/>
+        </p:nvSpPr>
+        <p:spPr>
+          <a:xfrm>
+            <a:off x="457200" y="2935224"/>
+            <a:ext cx="1965960" cy="301752"/>
+          </a:xfrm>
+          <a:prstGeom prst="rect">
+            <a:avLst/>
+          </a:prstGeom>
+          <a:noFill/>
+          <a:ln/>
+        </p:spPr>
+        <p:txBody>
+          <a:bodyPr wrap="square" lIns="0" tIns="0" rIns="0" bIns="0" rtlCol="0" anchor="ctr"/>
+          <a:lstStyle/>
+          <a:p>
+            <a:pPr indent="0" marL="0">
+              <a:buNone/>
+            </a:pPr>
+            <a:r>
+              <a:rPr lang="en-US" sz="1200" b="1" dirty="0">
+                <a:solidFill>
+                  <a:srgbClr val="FFFFFF"/>
+                </a:solidFill>
+                <a:latin typeface="Calibri" pitchFamily="34" charset="0"/>
+                <a:ea typeface="Calibri" pitchFamily="34" charset="-122"/>
+                <a:cs typeface="Calibri" pitchFamily="34" charset="-120"/>
+              </a:rPr>
+              <a:t>Container disposal</a:t>
+            </a:r>
+            <a:endParaRPr lang="en-US" sz="1200" dirty="0"/>
+          </a:p>
+        </p:txBody>
+      </p:sp>
+      <p:sp>
+        <p:nvSpPr>
+          <p:cNvPr id="16" name="Text 14"/>
+          <p:cNvSpPr txBox="1"/>
+          <p:nvPr/>
+        </p:nvSpPr>
+        <p:spPr>
+          <a:xfrm>
+            <a:off x="2468880" y="2935224"/>
+            <a:ext cx="3017520" cy="301752"/>
+          </a:xfrm>
+          <a:prstGeom prst="rect">
+            <a:avLst/>
+          </a:prstGeom>
+          <a:noFill/>
+          <a:ln/>
+        </p:spPr>
+        <p:txBody>
+          <a:bodyPr wrap="square" lIns="0" tIns="0" rIns="0" bIns="0" rtlCol="0" anchor="ctr"/>
+          <a:lstStyle/>
+          <a:p>
+            <a:pPr indent="0" marL="0">
+              <a:buNone/>
+            </a:pPr>
+            <a:r>
+              <a:rPr lang="en-US" sz="1050" dirty="0">
+                <a:solidFill>
+                  <a:srgbClr val="D5E8DA"/>
+                </a:solidFill>
+                <a:latin typeface="Calibri" pitchFamily="34" charset="0"/>
+                <a:ea typeface="Calibri" pitchFamily="34" charset="-122"/>
+                <a:cs typeface="Calibri" pitchFamily="34" charset="-120"/>
+              </a:rPr>
+              <a:t>collection points</a:t>
+            </a:r>
+            <a:endParaRPr lang="en-US" sz="1050" dirty="0"/>
+          </a:p>
+        </p:txBody>
+      </p:sp>
+      <p:sp>
+        <p:nvSpPr>
+          <p:cNvPr id="17" name="Text 15"/>
+          <p:cNvSpPr txBox="1"/>
+          <p:nvPr/>
+        </p:nvSpPr>
+        <p:spPr>
+          <a:xfrm>
+            <a:off x="457200" y="3264408"/>
+            <a:ext cx="1965960" cy="301752"/>
+          </a:xfrm>
+          <a:prstGeom prst="rect">
+            <a:avLst/>
+          </a:prstGeom>
+          <a:noFill/>
+          <a:ln/>
+        </p:spPr>
+        <p:txBody>
+          <a:bodyPr wrap="square" lIns="0" tIns="0" rIns="0" bIns="0" rtlCol="0" anchor="ctr"/>
+          <a:lstStyle/>
+          <a:p>
+            <a:pPr indent="0" marL="0">
+              <a:buNone/>
+            </a:pPr>
+            <a:r>
+              <a:rPr lang="en-US" sz="1200" b="1" dirty="0">
+                <a:solidFill>
+                  <a:srgbClr val="FFFFFF"/>
+                </a:solidFill>
+                <a:latin typeface="Calibri" pitchFamily="34" charset="0"/>
+                <a:ea typeface="Calibri" pitchFamily="34" charset="-122"/>
+                <a:cs typeface="Calibri" pitchFamily="34" charset="-120"/>
+              </a:rPr>
+              <a:t>AgriStack + KCC</a:t>
+            </a:r>
+            <a:endParaRPr lang="en-US" sz="1200" dirty="0"/>
+          </a:p>
+        </p:txBody>
+      </p:sp>
+      <p:sp>
+        <p:nvSpPr>
+          <p:cNvPr id="18" name="Text 16"/>
+          <p:cNvSpPr txBox="1"/>
+          <p:nvPr/>
+        </p:nvSpPr>
+        <p:spPr>
+          <a:xfrm>
+            <a:off x="2468880" y="3264408"/>
+            <a:ext cx="3017520" cy="301752"/>
+          </a:xfrm>
+          <a:prstGeom prst="rect">
+            <a:avLst/>
+          </a:prstGeom>
+          <a:noFill/>
+          <a:ln/>
+        </p:spPr>
+        <p:txBody>
+          <a:bodyPr wrap="square" lIns="0" tIns="0" rIns="0" bIns="0" rtlCol="0" anchor="ctr"/>
+          <a:lstStyle/>
+          <a:p>
+            <a:pPr indent="0" marL="0">
+              <a:buNone/>
+            </a:pPr>
+            <a:r>
+              <a:rPr lang="en-US" sz="1050" dirty="0">
+                <a:solidFill>
+                  <a:srgbClr val="D5E8DA"/>
+                </a:solidFill>
+                <a:latin typeface="Calibri" pitchFamily="34" charset="0"/>
+                <a:ea typeface="Calibri" pitchFamily="34" charset="-122"/>
+                <a:cs typeface="Calibri" pitchFamily="34" charset="-120"/>
+              </a:rPr>
+              <a:t>farmer ID, Kisan Call Centre hand-off</a:t>
+            </a:r>
+            <a:endParaRPr lang="en-US" sz="1050" dirty="0"/>
+          </a:p>
+        </p:txBody>
+      </p:sp>
+      <p:sp>
+        <p:nvSpPr>
+          <p:cNvPr id="19" name="Text 17"/>
+          <p:cNvSpPr txBox="1"/>
+          <p:nvPr/>
+        </p:nvSpPr>
+        <p:spPr>
+          <a:xfrm>
+            <a:off x="457200" y="3593592"/>
+            <a:ext cx="1965960" cy="301752"/>
+          </a:xfrm>
+          <a:prstGeom prst="rect">
+            <a:avLst/>
+          </a:prstGeom>
+          <a:noFill/>
+          <a:ln/>
+        </p:spPr>
+        <p:txBody>
+          <a:bodyPr wrap="square" lIns="0" tIns="0" rIns="0" bIns="0" rtlCol="0" anchor="ctr"/>
+          <a:lstStyle/>
+          <a:p>
+            <a:pPr indent="0" marL="0">
+              <a:buNone/>
+            </a:pPr>
+            <a:r>
+              <a:rPr lang="en-US" sz="1200" b="1" dirty="0">
+                <a:solidFill>
+                  <a:srgbClr val="FFFFFF"/>
+                </a:solidFill>
+                <a:latin typeface="Calibri" pitchFamily="34" charset="0"/>
+                <a:ea typeface="Calibri" pitchFamily="34" charset="-122"/>
+                <a:cs typeface="Calibri" pitchFamily="34" charset="-120"/>
+              </a:rPr>
+              <a:t>Official QR registry</a:t>
+            </a:r>
+            <a:endParaRPr lang="en-US" sz="1200" dirty="0"/>
+          </a:p>
+        </p:txBody>
+      </p:sp>
+      <p:sp>
+        <p:nvSpPr>
+          <p:cNvPr id="20" name="Text 18"/>
+          <p:cNvSpPr txBox="1"/>
+          <p:nvPr/>
+        </p:nvSpPr>
+        <p:spPr>
+          <a:xfrm>
+            <a:off x="2468880" y="3593592"/>
+            <a:ext cx="3017520" cy="301752"/>
+          </a:xfrm>
+          <a:prstGeom prst="rect">
+            <a:avLst/>
+          </a:prstGeom>
+          <a:noFill/>
+          <a:ln/>
+        </p:spPr>
+        <p:txBody>
+          <a:bodyPr wrap="square" lIns="0" tIns="0" rIns="0" bIns="0" rtlCol="0" anchor="ctr"/>
+          <a:lstStyle/>
+          <a:p>
+            <a:pPr indent="0" marL="0">
+              <a:buNone/>
+            </a:pPr>
+            <a:r>
+              <a:rPr lang="en-US" sz="1050" dirty="0">
+                <a:solidFill>
+                  <a:srgbClr val="D5E8DA"/>
+                </a:solidFill>
+                <a:latin typeface="Calibri" pitchFamily="34" charset="0"/>
+                <a:ea typeface="Calibri" pitchFamily="34" charset="-122"/>
+                <a:cs typeface="Calibri" pitchFamily="34" charset="-120"/>
+              </a:rPr>
+              <a:t>verify QR once a central registry exists</a:t>
+            </a:r>
+            <a:endParaRPr lang="en-US" sz="1050" dirty="0"/>
+          </a:p>
+        </p:txBody>
+      </p:sp>
+      <p:sp>
+        <p:nvSpPr>
+          <p:cNvPr id="21" name="Shape 19"/>
           <p:cNvSpPr/>
           <p:nvPr/>
         </p:nvSpPr>
@@ -2650,7 +2658,7 @@
       </p:sp>
       <p:sp>
         <p:nvSpPr>
-          <p:cNvPr id="12" name="Text 10"/>
+          <p:cNvPr id="22" name="Text 20"/>
           <p:cNvSpPr txBox="1"/>
           <p:nvPr/>
         </p:nvSpPr>
@@ -2689,7 +2697,7 @@
       </p:sp>
       <p:sp>
         <p:nvSpPr>
-          <p:cNvPr id="13" name="Text 11"/>
+          <p:cNvPr id="23" name="Text 21"/>
           <p:cNvSpPr txBox="1"/>
           <p:nvPr/>
         </p:nvSpPr>
@@ -2728,7 +2736,7 @@
       </p:sp>
       <p:sp>
         <p:nvSpPr>
-          <p:cNvPr id="14" name="Text 12"/>
+          <p:cNvPr id="24" name="Text 22"/>
           <p:cNvSpPr txBox="1"/>
           <p:nvPr/>
         </p:nvSpPr>
@@ -2767,13 +2775,13 @@
       </p:sp>
       <p:sp>
         <p:nvSpPr>
-          <p:cNvPr id="15" name="Text 13"/>
-          <p:cNvSpPr txBox="1"/>
-          <p:nvPr/>
-        </p:nvSpPr>
-        <p:spPr>
-          <a:xfrm>
-            <a:off x="457200" y="3977640"/>
+          <p:cNvPr id="25" name="Text 23"/>
+          <p:cNvSpPr txBox="1"/>
+          <p:nvPr/>
+        </p:nvSpPr>
+        <p:spPr>
+          <a:xfrm>
+            <a:off x="457200" y="4114800"/>
             <a:ext cx="8229600" cy="548640"/>
           </a:xfrm>
           <a:prstGeom prst="rect">
@@ -6310,68 +6318,40 @@
           </a:p>
         </p:txBody>
       </p:sp>
-      <p:sp>
-        <p:nvSpPr>
-          <p:cNvPr id="3" name="Shape 1"/>
-          <p:cNvSpPr/>
-          <p:nvPr/>
-        </p:nvSpPr>
-        <p:spPr>
-          <a:xfrm>
-            <a:off x="457200" y="1280160"/>
-            <a:ext cx="1499616" cy="2377440"/>
-          </a:xfrm>
-          <a:prstGeom prst="roundRect">
-            <a:avLst>
-              <a:gd name="adj" fmla="val 7317"/>
-            </a:avLst>
-          </a:prstGeom>
-          <a:solidFill>
-            <a:srgbClr val="FFFFFF"/>
-          </a:solidFill>
-          <a:ln w="9525">
-            <a:solidFill>
-              <a:srgbClr val="D6DDD7"/>
-            </a:solidFill>
-            <a:prstDash val="solid"/>
-          </a:ln>
-        </p:spPr>
-      </p:sp>
-      <p:sp>
-        <p:nvSpPr>
-          <p:cNvPr id="4" name="Shape 2"/>
-          <p:cNvSpPr/>
-          <p:nvPr/>
-        </p:nvSpPr>
-        <p:spPr>
-          <a:xfrm>
-            <a:off x="932688" y="1463040"/>
-            <a:ext cx="548640" cy="548640"/>
-          </a:xfrm>
-          <a:prstGeom prst="ellipse">
-            <a:avLst/>
-          </a:prstGeom>
-          <a:solidFill>
-            <a:srgbClr val="14532D"/>
-          </a:solidFill>
-          <a:ln w="12700">
-            <a:solidFill>
-              <a:srgbClr val="14532D"/>
-            </a:solidFill>
-            <a:prstDash val="solid"/>
-          </a:ln>
-        </p:spPr>
-      </p:sp>
-      <p:sp>
-        <p:nvSpPr>
-          <p:cNvPr id="5" name="Text 3"/>
-          <p:cNvSpPr txBox="1"/>
-          <p:nvPr/>
-        </p:nvSpPr>
-        <p:spPr>
-          <a:xfrm>
-            <a:off x="932688" y="1463040"/>
-            <a:ext cx="548640" cy="548640"/>
+      <p:pic>
+        <p:nvPicPr>
+          <p:cNvPr id="3" name="Image 0" descr="1 Scan">    </p:cNvPr>
+          <p:cNvPicPr>
+            <a:picLocks noChangeAspect="1"/>
+          </p:cNvPicPr>
+          <p:nvPr/>
+        </p:nvPicPr>
+        <p:blipFill>
+          <a:blip r:embed="rId1"/>
+          <a:stretch>
+            <a:fillRect/>
+          </a:stretch>
+        </p:blipFill>
+        <p:spPr>
+          <a:xfrm>
+            <a:off x="566928" y="960120"/>
+            <a:ext cx="1280160" cy="2560320"/>
+          </a:xfrm>
+          <a:prstGeom prst="rect">
+            <a:avLst/>
+          </a:prstGeom>
+        </p:spPr>
+      </p:pic>
+      <p:sp>
+        <p:nvSpPr>
+          <p:cNvPr id="4" name="Text 1"/>
+          <p:cNvSpPr txBox="1"/>
+          <p:nvPr/>
+        </p:nvSpPr>
+        <p:spPr>
+          <a:xfrm>
+            <a:off x="457200" y="3611880"/>
+            <a:ext cx="1499616" cy="292608"/>
           </a:xfrm>
           <a:prstGeom prst="rect">
             <a:avLst/>
@@ -6387,30 +6367,93 @@
               <a:buNone/>
             </a:pPr>
             <a:r>
-              <a:rPr lang="en-US" sz="1800" b="1" dirty="0">
-                <a:solidFill>
-                  <a:srgbClr val="FFFFFF"/>
+              <a:rPr lang="en-US" sz="1300" b="1" dirty="0">
+                <a:solidFill>
+                  <a:srgbClr val="1D231F"/>
+                </a:solidFill>
+                <a:latin typeface="Cambria" pitchFamily="34" charset="0"/>
+                <a:ea typeface="Cambria" pitchFamily="34" charset="-122"/>
+                <a:cs typeface="Cambria" pitchFamily="34" charset="-120"/>
+              </a:rPr>
+              <a:t>1 Scan</a:t>
+            </a:r>
+            <a:endParaRPr lang="en-US" sz="1300" dirty="0"/>
+          </a:p>
+        </p:txBody>
+      </p:sp>
+      <p:sp>
+        <p:nvSpPr>
+          <p:cNvPr id="5" name="Text 2"/>
+          <p:cNvSpPr txBox="1"/>
+          <p:nvPr/>
+        </p:nvSpPr>
+        <p:spPr>
+          <a:xfrm>
+            <a:off x="457200" y="3904488"/>
+            <a:ext cx="1499616" cy="365760"/>
+          </a:xfrm>
+          <a:prstGeom prst="rect">
+            <a:avLst/>
+          </a:prstGeom>
+          <a:noFill/>
+          <a:ln/>
+        </p:spPr>
+        <p:txBody>
+          <a:bodyPr wrap="square" lIns="0" tIns="0" rIns="0" bIns="0" rtlCol="0" anchor="ctr"/>
+          <a:lstStyle/>
+          <a:p>
+            <a:pPr algn="ctr" indent="0" marL="0">
+              <a:buNone/>
+            </a:pPr>
+            <a:r>
+              <a:rPr lang="en-US" sz="1050" dirty="0">
+                <a:solidFill>
+                  <a:srgbClr val="5D665F"/>
                 </a:solidFill>
                 <a:latin typeface="Calibri" pitchFamily="34" charset="0"/>
                 <a:ea typeface="Calibri" pitchFamily="34" charset="-122"/>
                 <a:cs typeface="Calibri" pitchFamily="34" charset="-120"/>
               </a:rPr>
-              <a:t>📷</a:t>
-            </a:r>
-            <a:endParaRPr lang="en-US" sz="1800" dirty="0"/>
-          </a:p>
-        </p:txBody>
-      </p:sp>
-      <p:sp>
-        <p:nvSpPr>
-          <p:cNvPr id="6" name="Text 4"/>
-          <p:cNvSpPr txBox="1"/>
-          <p:nvPr/>
-        </p:nvSpPr>
-        <p:spPr>
-          <a:xfrm>
-            <a:off x="548640" y="2148840"/>
-            <a:ext cx="1316736" cy="365760"/>
+              <a:t>QR or label photo</a:t>
+            </a:r>
+            <a:endParaRPr lang="en-US" sz="1050" dirty="0"/>
+          </a:p>
+        </p:txBody>
+      </p:sp>
+      <p:pic>
+        <p:nvPicPr>
+          <p:cNvPr id="6" name="Image 1" descr="2 Verify">    </p:cNvPr>
+          <p:cNvPicPr>
+            <a:picLocks noChangeAspect="1"/>
+          </p:cNvPicPr>
+          <p:nvPr/>
+        </p:nvPicPr>
+        <p:blipFill>
+          <a:blip r:embed="rId2"/>
+          <a:stretch>
+            <a:fillRect/>
+          </a:stretch>
+        </p:blipFill>
+        <p:spPr>
+          <a:xfrm>
+            <a:off x="2249424" y="960120"/>
+            <a:ext cx="1280160" cy="2560320"/>
+          </a:xfrm>
+          <a:prstGeom prst="rect">
+            <a:avLst/>
+          </a:prstGeom>
+        </p:spPr>
+      </p:pic>
+      <p:sp>
+        <p:nvSpPr>
+          <p:cNvPr id="7" name="Text 3"/>
+          <p:cNvSpPr txBox="1"/>
+          <p:nvPr/>
+        </p:nvSpPr>
+        <p:spPr>
+          <a:xfrm>
+            <a:off x="2139696" y="3611880"/>
+            <a:ext cx="1499616" cy="292608"/>
           </a:xfrm>
           <a:prstGeom prst="rect">
             <a:avLst/>
@@ -6426,7 +6469,7 @@
               <a:buNone/>
             </a:pPr>
             <a:r>
-              <a:rPr lang="en-US" sz="1600" b="1" dirty="0">
+              <a:rPr lang="en-US" sz="1300" b="1" dirty="0">
                 <a:solidFill>
                   <a:srgbClr val="1D231F"/>
                 </a:solidFill>
@@ -6434,22 +6477,22 @@
                 <a:ea typeface="Cambria" pitchFamily="34" charset="-122"/>
                 <a:cs typeface="Cambria" pitchFamily="34" charset="-120"/>
               </a:rPr>
-              <a:t>Scan</a:t>
-            </a:r>
-            <a:endParaRPr lang="en-US" sz="1600" dirty="0"/>
-          </a:p>
-        </p:txBody>
-      </p:sp>
-      <p:sp>
-        <p:nvSpPr>
-          <p:cNvPr id="7" name="Text 5"/>
-          <p:cNvSpPr txBox="1"/>
-          <p:nvPr/>
-        </p:nvSpPr>
-        <p:spPr>
-          <a:xfrm>
-            <a:off x="566928" y="2560320"/>
-            <a:ext cx="1280160" cy="914400"/>
+              <a:t>2 Verify</a:t>
+            </a:r>
+            <a:endParaRPr lang="en-US" sz="1300" dirty="0"/>
+          </a:p>
+        </p:txBody>
+      </p:sp>
+      <p:sp>
+        <p:nvSpPr>
+          <p:cNvPr id="8" name="Text 4"/>
+          <p:cNvSpPr txBox="1"/>
+          <p:nvPr/>
+        </p:nvSpPr>
+        <p:spPr>
+          <a:xfrm>
+            <a:off x="2139696" y="3904488"/>
+            <a:ext cx="1499616" cy="365760"/>
           </a:xfrm>
           <a:prstGeom prst="rect">
             <a:avLst/>
@@ -6465,7 +6508,7 @@
               <a:buNone/>
             </a:pPr>
             <a:r>
-              <a:rPr lang="en-US" sz="1200" dirty="0">
+              <a:rPr lang="en-US" sz="1050" dirty="0">
                 <a:solidFill>
                   <a:srgbClr val="5D665F"/>
                 </a:solidFill>
@@ -6473,74 +6516,46 @@
                 <a:ea typeface="Calibri" pitchFamily="34" charset="-122"/>
                 <a:cs typeface="Calibri" pitchFamily="34" charset="-120"/>
               </a:rPr>
-              <a:t>QR, label photo or dealer bill</a:t>
-            </a:r>
-            <a:endParaRPr lang="en-US" sz="1200" dirty="0"/>
-          </a:p>
-        </p:txBody>
-      </p:sp>
-      <p:sp>
-        <p:nvSpPr>
-          <p:cNvPr id="8" name="Shape 6"/>
-          <p:cNvSpPr/>
-          <p:nvPr/>
-        </p:nvSpPr>
-        <p:spPr>
-          <a:xfrm>
-            <a:off x="2139696" y="1280160"/>
-            <a:ext cx="1499616" cy="2377440"/>
-          </a:xfrm>
-          <a:prstGeom prst="roundRect">
-            <a:avLst>
-              <a:gd name="adj" fmla="val 7317"/>
-            </a:avLst>
-          </a:prstGeom>
-          <a:solidFill>
-            <a:srgbClr val="FFFFFF"/>
-          </a:solidFill>
-          <a:ln w="9525">
-            <a:solidFill>
-              <a:srgbClr val="D6DDD7"/>
-            </a:solidFill>
-            <a:prstDash val="solid"/>
-          </a:ln>
-        </p:spPr>
-      </p:sp>
-      <p:sp>
-        <p:nvSpPr>
-          <p:cNvPr id="9" name="Shape 7"/>
-          <p:cNvSpPr/>
-          <p:nvPr/>
-        </p:nvSpPr>
-        <p:spPr>
-          <a:xfrm>
-            <a:off x="2615184" y="1463040"/>
-            <a:ext cx="548640" cy="548640"/>
-          </a:xfrm>
-          <a:prstGeom prst="ellipse">
-            <a:avLst/>
-          </a:prstGeom>
-          <a:solidFill>
-            <a:srgbClr val="1F7A3A"/>
-          </a:solidFill>
-          <a:ln w="12700">
-            <a:solidFill>
-              <a:srgbClr val="1F7A3A"/>
-            </a:solidFill>
-            <a:prstDash val="solid"/>
-          </a:ln>
-        </p:spPr>
-      </p:sp>
-      <p:sp>
-        <p:nvSpPr>
-          <p:cNvPr id="10" name="Text 8"/>
-          <p:cNvSpPr txBox="1"/>
-          <p:nvPr/>
-        </p:nvSpPr>
-        <p:spPr>
-          <a:xfrm>
-            <a:off x="2615184" y="1463040"/>
-            <a:ext cx="548640" cy="548640"/>
+              <a:t>Registry, bans, crop + pest</a:t>
+            </a:r>
+            <a:endParaRPr lang="en-US" sz="1050" dirty="0"/>
+          </a:p>
+        </p:txBody>
+      </p:sp>
+      <p:pic>
+        <p:nvPicPr>
+          <p:cNvPr id="9" name="Image 2" descr="3 Dose">    </p:cNvPr>
+          <p:cNvPicPr>
+            <a:picLocks noChangeAspect="1"/>
+          </p:cNvPicPr>
+          <p:nvPr/>
+        </p:nvPicPr>
+        <p:blipFill>
+          <a:blip r:embed="rId3"/>
+          <a:stretch>
+            <a:fillRect/>
+          </a:stretch>
+        </p:blipFill>
+        <p:spPr>
+          <a:xfrm>
+            <a:off x="3931920" y="960120"/>
+            <a:ext cx="1280160" cy="2560320"/>
+          </a:xfrm>
+          <a:prstGeom prst="rect">
+            <a:avLst/>
+          </a:prstGeom>
+        </p:spPr>
+      </p:pic>
+      <p:sp>
+        <p:nvSpPr>
+          <p:cNvPr id="10" name="Text 5"/>
+          <p:cNvSpPr txBox="1"/>
+          <p:nvPr/>
+        </p:nvSpPr>
+        <p:spPr>
+          <a:xfrm>
+            <a:off x="3822192" y="3611880"/>
+            <a:ext cx="1499616" cy="292608"/>
           </a:xfrm>
           <a:prstGeom prst="rect">
             <a:avLst/>
@@ -6556,30 +6571,93 @@
               <a:buNone/>
             </a:pPr>
             <a:r>
-              <a:rPr lang="en-US" sz="1800" b="1" dirty="0">
-                <a:solidFill>
-                  <a:srgbClr val="FFFFFF"/>
+              <a:rPr lang="en-US" sz="1300" b="1" dirty="0">
+                <a:solidFill>
+                  <a:srgbClr val="1D231F"/>
+                </a:solidFill>
+                <a:latin typeface="Cambria" pitchFamily="34" charset="0"/>
+                <a:ea typeface="Cambria" pitchFamily="34" charset="-122"/>
+                <a:cs typeface="Cambria" pitchFamily="34" charset="-120"/>
+              </a:rPr>
+              <a:t>3 Dose</a:t>
+            </a:r>
+            <a:endParaRPr lang="en-US" sz="1300" dirty="0"/>
+          </a:p>
+        </p:txBody>
+      </p:sp>
+      <p:sp>
+        <p:nvSpPr>
+          <p:cNvPr id="11" name="Text 6"/>
+          <p:cNvSpPr txBox="1"/>
+          <p:nvPr/>
+        </p:nvSpPr>
+        <p:spPr>
+          <a:xfrm>
+            <a:off x="3822192" y="3904488"/>
+            <a:ext cx="1499616" cy="365760"/>
+          </a:xfrm>
+          <a:prstGeom prst="rect">
+            <a:avLst/>
+          </a:prstGeom>
+          <a:noFill/>
+          <a:ln/>
+        </p:spPr>
+        <p:txBody>
+          <a:bodyPr wrap="square" lIns="0" tIns="0" rIns="0" bIns="0" rtlCol="0" anchor="ctr"/>
+          <a:lstStyle/>
+          <a:p>
+            <a:pPr algn="ctr" indent="0" marL="0">
+              <a:buNone/>
+            </a:pPr>
+            <a:r>
+              <a:rPr lang="en-US" sz="1050" dirty="0">
+                <a:solidFill>
+                  <a:srgbClr val="5D665F"/>
                 </a:solidFill>
                 <a:latin typeface="Calibri" pitchFamily="34" charset="0"/>
                 <a:ea typeface="Calibri" pitchFamily="34" charset="-122"/>
                 <a:cs typeface="Calibri" pitchFamily="34" charset="-120"/>
               </a:rPr>
-              <a:t>✔</a:t>
-            </a:r>
-            <a:endParaRPr lang="en-US" sz="1800" dirty="0"/>
-          </a:p>
-        </p:txBody>
-      </p:sp>
-      <p:sp>
-        <p:nvSpPr>
-          <p:cNvPr id="11" name="Text 9"/>
-          <p:cNvSpPr txBox="1"/>
-          <p:nvPr/>
-        </p:nvSpPr>
-        <p:spPr>
-          <a:xfrm>
-            <a:off x="2231136" y="2148840"/>
-            <a:ext cx="1316736" cy="365760"/>
+              <a:t>Per tank, gear, weather</a:t>
+            </a:r>
+            <a:endParaRPr lang="en-US" sz="1050" dirty="0"/>
+          </a:p>
+        </p:txBody>
+      </p:sp>
+      <p:pic>
+        <p:nvPicPr>
+          <p:cNvPr id="12" name="Image 3" descr="4 Safe harvest">    </p:cNvPr>
+          <p:cNvPicPr>
+            <a:picLocks noChangeAspect="1"/>
+          </p:cNvPicPr>
+          <p:nvPr/>
+        </p:nvPicPr>
+        <p:blipFill>
+          <a:blip r:embed="rId4"/>
+          <a:stretch>
+            <a:fillRect/>
+          </a:stretch>
+        </p:blipFill>
+        <p:spPr>
+          <a:xfrm>
+            <a:off x="5614416" y="960120"/>
+            <a:ext cx="1280160" cy="2560320"/>
+          </a:xfrm>
+          <a:prstGeom prst="rect">
+            <a:avLst/>
+          </a:prstGeom>
+        </p:spPr>
+      </p:pic>
+      <p:sp>
+        <p:nvSpPr>
+          <p:cNvPr id="13" name="Text 7"/>
+          <p:cNvSpPr txBox="1"/>
+          <p:nvPr/>
+        </p:nvSpPr>
+        <p:spPr>
+          <a:xfrm>
+            <a:off x="5504688" y="3611880"/>
+            <a:ext cx="1499616" cy="292608"/>
           </a:xfrm>
           <a:prstGeom prst="rect">
             <a:avLst/>
@@ -6595,7 +6673,7 @@
               <a:buNone/>
             </a:pPr>
             <a:r>
-              <a:rPr lang="en-US" sz="1600" b="1" dirty="0">
+              <a:rPr lang="en-US" sz="1300" b="1" dirty="0">
                 <a:solidFill>
                   <a:srgbClr val="1D231F"/>
                 </a:solidFill>
@@ -6603,22 +6681,22 @@
                 <a:ea typeface="Cambria" pitchFamily="34" charset="-122"/>
                 <a:cs typeface="Cambria" pitchFamily="34" charset="-120"/>
               </a:rPr>
-              <a:t>Verify</a:t>
-            </a:r>
-            <a:endParaRPr lang="en-US" sz="1600" dirty="0"/>
-          </a:p>
-        </p:txBody>
-      </p:sp>
-      <p:sp>
-        <p:nvSpPr>
-          <p:cNvPr id="12" name="Text 10"/>
-          <p:cNvSpPr txBox="1"/>
-          <p:nvPr/>
-        </p:nvSpPr>
-        <p:spPr>
-          <a:xfrm>
-            <a:off x="2249424" y="2560320"/>
-            <a:ext cx="1280160" cy="914400"/>
+              <a:t>4 Safe harvest</a:t>
+            </a:r>
+            <a:endParaRPr lang="en-US" sz="1300" dirty="0"/>
+          </a:p>
+        </p:txBody>
+      </p:sp>
+      <p:sp>
+        <p:nvSpPr>
+          <p:cNvPr id="14" name="Text 8"/>
+          <p:cNvSpPr txBox="1"/>
+          <p:nvPr/>
+        </p:nvSpPr>
+        <p:spPr>
+          <a:xfrm>
+            <a:off x="5504688" y="3904488"/>
+            <a:ext cx="1499616" cy="365760"/>
           </a:xfrm>
           <a:prstGeom prst="rect">
             <a:avLst/>
@@ -6634,7 +6712,7 @@
               <a:buNone/>
             </a:pPr>
             <a:r>
-              <a:rPr lang="en-US" sz="1200" dirty="0">
+              <a:rPr lang="en-US" sz="1050" dirty="0">
                 <a:solidFill>
                   <a:srgbClr val="5D665F"/>
                 </a:solidFill>
@@ -6642,74 +6720,46 @@
                 <a:ea typeface="Calibri" pitchFamily="34" charset="-122"/>
                 <a:cs typeface="Calibri" pitchFamily="34" charset="-120"/>
               </a:rPr>
-              <a:t>Registry, ban list, crop and pest</a:t>
-            </a:r>
-            <a:endParaRPr lang="en-US" sz="1200" dirty="0"/>
-          </a:p>
-        </p:txBody>
-      </p:sp>
-      <p:sp>
-        <p:nvSpPr>
-          <p:cNvPr id="13" name="Shape 11"/>
-          <p:cNvSpPr/>
-          <p:nvPr/>
-        </p:nvSpPr>
-        <p:spPr>
-          <a:xfrm>
-            <a:off x="3822192" y="1280160"/>
-            <a:ext cx="1499616" cy="2377440"/>
-          </a:xfrm>
-          <a:prstGeom prst="roundRect">
-            <a:avLst>
-              <a:gd name="adj" fmla="val 7317"/>
-            </a:avLst>
-          </a:prstGeom>
-          <a:solidFill>
-            <a:srgbClr val="FFFFFF"/>
-          </a:solidFill>
-          <a:ln w="9525">
-            <a:solidFill>
-              <a:srgbClr val="D6DDD7"/>
-            </a:solidFill>
-            <a:prstDash val="solid"/>
-          </a:ln>
-        </p:spPr>
-      </p:sp>
-      <p:sp>
-        <p:nvSpPr>
-          <p:cNvPr id="14" name="Shape 12"/>
-          <p:cNvSpPr/>
-          <p:nvPr/>
-        </p:nvSpPr>
-        <p:spPr>
-          <a:xfrm>
-            <a:off x="4297680" y="1463040"/>
-            <a:ext cx="548640" cy="548640"/>
-          </a:xfrm>
-          <a:prstGeom prst="ellipse">
-            <a:avLst/>
-          </a:prstGeom>
-          <a:solidFill>
-            <a:srgbClr val="14532D"/>
-          </a:solidFill>
-          <a:ln w="12700">
-            <a:solidFill>
-              <a:srgbClr val="14532D"/>
-            </a:solidFill>
-            <a:prstDash val="solid"/>
-          </a:ln>
-        </p:spPr>
-      </p:sp>
-      <p:sp>
-        <p:nvSpPr>
-          <p:cNvPr id="15" name="Text 13"/>
-          <p:cNvSpPr txBox="1"/>
-          <p:nvPr/>
-        </p:nvSpPr>
-        <p:spPr>
-          <a:xfrm>
-            <a:off x="4297680" y="1463040"/>
-            <a:ext cx="548640" cy="548640"/>
+              <a:t>Date + reminder</a:t>
+            </a:r>
+            <a:endParaRPr lang="en-US" sz="1050" dirty="0"/>
+          </a:p>
+        </p:txBody>
+      </p:sp>
+      <p:pic>
+        <p:nvPicPr>
+          <p:cNvPr id="15" name="Image 4" descr="5 Passport">    </p:cNvPr>
+          <p:cNvPicPr>
+            <a:picLocks noChangeAspect="1"/>
+          </p:cNvPicPr>
+          <p:nvPr/>
+        </p:nvPicPr>
+        <p:blipFill>
+          <a:blip r:embed="rId5"/>
+          <a:stretch>
+            <a:fillRect/>
+          </a:stretch>
+        </p:blipFill>
+        <p:spPr>
+          <a:xfrm>
+            <a:off x="7296912" y="960120"/>
+            <a:ext cx="1280160" cy="2560320"/>
+          </a:xfrm>
+          <a:prstGeom prst="rect">
+            <a:avLst/>
+          </a:prstGeom>
+        </p:spPr>
+      </p:pic>
+      <p:sp>
+        <p:nvSpPr>
+          <p:cNvPr id="16" name="Text 9"/>
+          <p:cNvSpPr txBox="1"/>
+          <p:nvPr/>
+        </p:nvSpPr>
+        <p:spPr>
+          <a:xfrm>
+            <a:off x="7187184" y="3611880"/>
+            <a:ext cx="1499616" cy="292608"/>
           </a:xfrm>
           <a:prstGeom prst="rect">
             <a:avLst/>
@@ -6725,30 +6775,69 @@
               <a:buNone/>
             </a:pPr>
             <a:r>
-              <a:rPr lang="en-US" sz="1800" b="1" dirty="0">
-                <a:solidFill>
-                  <a:srgbClr val="FFFFFF"/>
+              <a:rPr lang="en-US" sz="1300" b="1" dirty="0">
+                <a:solidFill>
+                  <a:srgbClr val="1D231F"/>
+                </a:solidFill>
+                <a:latin typeface="Cambria" pitchFamily="34" charset="0"/>
+                <a:ea typeface="Cambria" pitchFamily="34" charset="-122"/>
+                <a:cs typeface="Cambria" pitchFamily="34" charset="-120"/>
+              </a:rPr>
+              <a:t>5 Passport</a:t>
+            </a:r>
+            <a:endParaRPr lang="en-US" sz="1300" dirty="0"/>
+          </a:p>
+        </p:txBody>
+      </p:sp>
+      <p:sp>
+        <p:nvSpPr>
+          <p:cNvPr id="17" name="Text 10"/>
+          <p:cNvSpPr txBox="1"/>
+          <p:nvPr/>
+        </p:nvSpPr>
+        <p:spPr>
+          <a:xfrm>
+            <a:off x="7187184" y="3904488"/>
+            <a:ext cx="1499616" cy="365760"/>
+          </a:xfrm>
+          <a:prstGeom prst="rect">
+            <a:avLst/>
+          </a:prstGeom>
+          <a:noFill/>
+          <a:ln/>
+        </p:spPr>
+        <p:txBody>
+          <a:bodyPr wrap="square" lIns="0" tIns="0" rIns="0" bIns="0" rtlCol="0" anchor="ctr"/>
+          <a:lstStyle/>
+          <a:p>
+            <a:pPr algn="ctr" indent="0" marL="0">
+              <a:buNone/>
+            </a:pPr>
+            <a:r>
+              <a:rPr lang="en-US" sz="1050" dirty="0">
+                <a:solidFill>
+                  <a:srgbClr val="5D665F"/>
                 </a:solidFill>
                 <a:latin typeface="Calibri" pitchFamily="34" charset="0"/>
                 <a:ea typeface="Calibri" pitchFamily="34" charset="-122"/>
                 <a:cs typeface="Calibri" pitchFamily="34" charset="-120"/>
               </a:rPr>
-              <a:t>🥛</a:t>
-            </a:r>
-            <a:endParaRPr lang="en-US" sz="1800" dirty="0"/>
-          </a:p>
-        </p:txBody>
-      </p:sp>
-      <p:sp>
-        <p:nvSpPr>
-          <p:cNvPr id="16" name="Text 14"/>
-          <p:cNvSpPr txBox="1"/>
-          <p:nvPr/>
-        </p:nvSpPr>
-        <p:spPr>
-          <a:xfrm>
-            <a:off x="3913632" y="2148840"/>
-            <a:ext cx="1316736" cy="365760"/>
+              <a:t>QR record for the buyer</a:t>
+            </a:r>
+            <a:endParaRPr lang="en-US" sz="1050" dirty="0"/>
+          </a:p>
+        </p:txBody>
+      </p:sp>
+      <p:sp>
+        <p:nvSpPr>
+          <p:cNvPr id="18" name="Text 11"/>
+          <p:cNvSpPr txBox="1"/>
+          <p:nvPr/>
+        </p:nvSpPr>
+        <p:spPr>
+          <a:xfrm>
+            <a:off x="457200" y="4343400"/>
+            <a:ext cx="8229600" cy="365760"/>
           </a:xfrm>
           <a:prstGeom prst="rect">
             <a:avLst/>
@@ -6764,433 +6853,17 @@
               <a:buNone/>
             </a:pPr>
             <a:r>
-              <a:rPr lang="en-US" sz="1600" b="1" dirty="0">
-                <a:solidFill>
-                  <a:srgbClr val="1D231F"/>
-                </a:solidFill>
-                <a:latin typeface="Cambria" pitchFamily="34" charset="0"/>
-                <a:ea typeface="Cambria" pitchFamily="34" charset="-122"/>
-                <a:cs typeface="Cambria" pitchFamily="34" charset="-120"/>
-              </a:rPr>
-              <a:t>Dose</a:t>
-            </a:r>
-            <a:endParaRPr lang="en-US" sz="1600" dirty="0"/>
-          </a:p>
-        </p:txBody>
-      </p:sp>
-      <p:sp>
-        <p:nvSpPr>
-          <p:cNvPr id="17" name="Text 15"/>
-          <p:cNvSpPr txBox="1"/>
-          <p:nvPr/>
-        </p:nvSpPr>
-        <p:spPr>
-          <a:xfrm>
-            <a:off x="3931920" y="2560320"/>
-            <a:ext cx="1280160" cy="914400"/>
-          </a:xfrm>
-          <a:prstGeom prst="rect">
-            <a:avLst/>
-          </a:prstGeom>
-          <a:noFill/>
-          <a:ln/>
-        </p:spPr>
-        <p:txBody>
-          <a:bodyPr wrap="square" lIns="0" tIns="0" rIns="0" bIns="0" rtlCol="0" anchor="ctr"/>
-          <a:lstStyle/>
-          <a:p>
-            <a:pPr algn="ctr" indent="0" marL="0">
-              <a:buNone/>
-            </a:pPr>
-            <a:r>
-              <a:rPr lang="en-US" sz="1200" dirty="0">
-                <a:solidFill>
-                  <a:srgbClr val="5D665F"/>
+              <a:rPr lang="en-US" sz="1300" b="1" dirty="0">
+                <a:solidFill>
+                  <a:srgbClr val="14532D"/>
                 </a:solidFill>
                 <a:latin typeface="Calibri" pitchFamily="34" charset="0"/>
                 <a:ea typeface="Calibri" pitchFamily="34" charset="-122"/>
                 <a:cs typeface="Calibri" pitchFamily="34" charset="-120"/>
               </a:rPr>
-              <a:t>ml per tank and number of tanks</a:t>
-            </a:r>
-            <a:endParaRPr lang="en-US" sz="1200" dirty="0"/>
-          </a:p>
-        </p:txBody>
-      </p:sp>
-      <p:sp>
-        <p:nvSpPr>
-          <p:cNvPr id="18" name="Shape 16"/>
-          <p:cNvSpPr/>
-          <p:nvPr/>
-        </p:nvSpPr>
-        <p:spPr>
-          <a:xfrm>
-            <a:off x="5504688" y="1280160"/>
-            <a:ext cx="1499616" cy="2377440"/>
-          </a:xfrm>
-          <a:prstGeom prst="roundRect">
-            <a:avLst>
-              <a:gd name="adj" fmla="val 7317"/>
-            </a:avLst>
-          </a:prstGeom>
-          <a:solidFill>
-            <a:srgbClr val="FFFFFF"/>
-          </a:solidFill>
-          <a:ln w="9525">
-            <a:solidFill>
-              <a:srgbClr val="D6DDD7"/>
-            </a:solidFill>
-            <a:prstDash val="solid"/>
-          </a:ln>
-        </p:spPr>
-      </p:sp>
-      <p:sp>
-        <p:nvSpPr>
-          <p:cNvPr id="19" name="Shape 17"/>
-          <p:cNvSpPr/>
-          <p:nvPr/>
-        </p:nvSpPr>
-        <p:spPr>
-          <a:xfrm>
-            <a:off x="5980176" y="1463040"/>
-            <a:ext cx="548640" cy="548640"/>
-          </a:xfrm>
-          <a:prstGeom prst="ellipse">
-            <a:avLst/>
-          </a:prstGeom>
-          <a:solidFill>
-            <a:srgbClr val="14532D"/>
-          </a:solidFill>
-          <a:ln w="12700">
-            <a:solidFill>
-              <a:srgbClr val="14532D"/>
-            </a:solidFill>
-            <a:prstDash val="solid"/>
-          </a:ln>
-        </p:spPr>
-      </p:sp>
-      <p:sp>
-        <p:nvSpPr>
-          <p:cNvPr id="20" name="Text 18"/>
-          <p:cNvSpPr txBox="1"/>
-          <p:nvPr/>
-        </p:nvSpPr>
-        <p:spPr>
-          <a:xfrm>
-            <a:off x="5980176" y="1463040"/>
-            <a:ext cx="548640" cy="548640"/>
-          </a:xfrm>
-          <a:prstGeom prst="rect">
-            <a:avLst/>
-          </a:prstGeom>
-          <a:noFill/>
-          <a:ln/>
-        </p:spPr>
-        <p:txBody>
-          <a:bodyPr wrap="square" lIns="0" tIns="0" rIns="0" bIns="0" rtlCol="0" anchor="ctr"/>
-          <a:lstStyle/>
-          <a:p>
-            <a:pPr algn="ctr" indent="0" marL="0">
-              <a:buNone/>
-            </a:pPr>
-            <a:r>
-              <a:rPr lang="en-US" sz="1800" b="1" dirty="0">
-                <a:solidFill>
-                  <a:srgbClr val="FFFFFF"/>
-                </a:solidFill>
-                <a:latin typeface="Calibri" pitchFamily="34" charset="0"/>
-                <a:ea typeface="Calibri" pitchFamily="34" charset="-122"/>
-                <a:cs typeface="Calibri" pitchFamily="34" charset="-120"/>
-              </a:rPr>
-              <a:t>📅</a:t>
-            </a:r>
-            <a:endParaRPr lang="en-US" sz="1800" dirty="0"/>
-          </a:p>
-        </p:txBody>
-      </p:sp>
-      <p:sp>
-        <p:nvSpPr>
-          <p:cNvPr id="21" name="Text 19"/>
-          <p:cNvSpPr txBox="1"/>
-          <p:nvPr/>
-        </p:nvSpPr>
-        <p:spPr>
-          <a:xfrm>
-            <a:off x="5596128" y="2148840"/>
-            <a:ext cx="1316736" cy="365760"/>
-          </a:xfrm>
-          <a:prstGeom prst="rect">
-            <a:avLst/>
-          </a:prstGeom>
-          <a:noFill/>
-          <a:ln/>
-        </p:spPr>
-        <p:txBody>
-          <a:bodyPr wrap="square" lIns="0" tIns="0" rIns="0" bIns="0" rtlCol="0" anchor="ctr"/>
-          <a:lstStyle/>
-          <a:p>
-            <a:pPr algn="ctr" indent="0" marL="0">
-              <a:buNone/>
-            </a:pPr>
-            <a:r>
-              <a:rPr lang="en-US" sz="1600" b="1" dirty="0">
-                <a:solidFill>
-                  <a:srgbClr val="1D231F"/>
-                </a:solidFill>
-                <a:latin typeface="Cambria" pitchFamily="34" charset="0"/>
-                <a:ea typeface="Cambria" pitchFamily="34" charset="-122"/>
-                <a:cs typeface="Cambria" pitchFamily="34" charset="-120"/>
-              </a:rPr>
-              <a:t>Safe harvest</a:t>
-            </a:r>
-            <a:endParaRPr lang="en-US" sz="1600" dirty="0"/>
-          </a:p>
-        </p:txBody>
-      </p:sp>
-      <p:sp>
-        <p:nvSpPr>
-          <p:cNvPr id="22" name="Text 20"/>
-          <p:cNvSpPr txBox="1"/>
-          <p:nvPr/>
-        </p:nvSpPr>
-        <p:spPr>
-          <a:xfrm>
-            <a:off x="5614416" y="2560320"/>
-            <a:ext cx="1280160" cy="914400"/>
-          </a:xfrm>
-          <a:prstGeom prst="rect">
-            <a:avLst/>
-          </a:prstGeom>
-          <a:noFill/>
-          <a:ln/>
-        </p:spPr>
-        <p:txBody>
-          <a:bodyPr wrap="square" lIns="0" tIns="0" rIns="0" bIns="0" rtlCol="0" anchor="ctr"/>
-          <a:lstStyle/>
-          <a:p>
-            <a:pPr algn="ctr" indent="0" marL="0">
-              <a:buNone/>
-            </a:pPr>
-            <a:r>
-              <a:rPr lang="en-US" sz="1200" dirty="0">
-                <a:solidFill>
-                  <a:srgbClr val="5D665F"/>
-                </a:solidFill>
-                <a:latin typeface="Calibri" pitchFamily="34" charset="0"/>
-                <a:ea typeface="Calibri" pitchFamily="34" charset="-122"/>
-                <a:cs typeface="Calibri" pitchFamily="34" charset="-120"/>
-              </a:rPr>
-              <a:t>Spray date + waiting period</a:t>
-            </a:r>
-            <a:endParaRPr lang="en-US" sz="1200" dirty="0"/>
-          </a:p>
-        </p:txBody>
-      </p:sp>
-      <p:sp>
-        <p:nvSpPr>
-          <p:cNvPr id="23" name="Shape 21"/>
-          <p:cNvSpPr/>
-          <p:nvPr/>
-        </p:nvSpPr>
-        <p:spPr>
-          <a:xfrm>
-            <a:off x="7187184" y="1280160"/>
-            <a:ext cx="1499616" cy="2377440"/>
-          </a:xfrm>
-          <a:prstGeom prst="roundRect">
-            <a:avLst>
-              <a:gd name="adj" fmla="val 7317"/>
-            </a:avLst>
-          </a:prstGeom>
-          <a:solidFill>
-            <a:srgbClr val="FFFFFF"/>
-          </a:solidFill>
-          <a:ln w="9525">
-            <a:solidFill>
-              <a:srgbClr val="D6DDD7"/>
-            </a:solidFill>
-            <a:prstDash val="solid"/>
-          </a:ln>
-        </p:spPr>
-      </p:sp>
-      <p:sp>
-        <p:nvSpPr>
-          <p:cNvPr id="24" name="Shape 22"/>
-          <p:cNvSpPr/>
-          <p:nvPr/>
-        </p:nvSpPr>
-        <p:spPr>
-          <a:xfrm>
-            <a:off x="7662672" y="1463040"/>
-            <a:ext cx="548640" cy="548640"/>
-          </a:xfrm>
-          <a:prstGeom prst="ellipse">
-            <a:avLst/>
-          </a:prstGeom>
-          <a:solidFill>
-            <a:srgbClr val="14532D"/>
-          </a:solidFill>
-          <a:ln w="12700">
-            <a:solidFill>
-              <a:srgbClr val="14532D"/>
-            </a:solidFill>
-            <a:prstDash val="solid"/>
-          </a:ln>
-        </p:spPr>
-      </p:sp>
-      <p:sp>
-        <p:nvSpPr>
-          <p:cNvPr id="25" name="Text 23"/>
-          <p:cNvSpPr txBox="1"/>
-          <p:nvPr/>
-        </p:nvSpPr>
-        <p:spPr>
-          <a:xfrm>
-            <a:off x="7662672" y="1463040"/>
-            <a:ext cx="548640" cy="548640"/>
-          </a:xfrm>
-          <a:prstGeom prst="rect">
-            <a:avLst/>
-          </a:prstGeom>
-          <a:noFill/>
-          <a:ln/>
-        </p:spPr>
-        <p:txBody>
-          <a:bodyPr wrap="square" lIns="0" tIns="0" rIns="0" bIns="0" rtlCol="0" anchor="ctr"/>
-          <a:lstStyle/>
-          <a:p>
-            <a:pPr algn="ctr" indent="0" marL="0">
-              <a:buNone/>
-            </a:pPr>
-            <a:r>
-              <a:rPr lang="en-US" sz="1800" b="1" dirty="0">
-                <a:solidFill>
-                  <a:srgbClr val="FFFFFF"/>
-                </a:solidFill>
-                <a:latin typeface="Calibri" pitchFamily="34" charset="0"/>
-                <a:ea typeface="Calibri" pitchFamily="34" charset="-122"/>
-                <a:cs typeface="Calibri" pitchFamily="34" charset="-120"/>
-              </a:rPr>
-              <a:t>🔳</a:t>
-            </a:r>
-            <a:endParaRPr lang="en-US" sz="1800" dirty="0"/>
-          </a:p>
-        </p:txBody>
-      </p:sp>
-      <p:sp>
-        <p:nvSpPr>
-          <p:cNvPr id="26" name="Text 24"/>
-          <p:cNvSpPr txBox="1"/>
-          <p:nvPr/>
-        </p:nvSpPr>
-        <p:spPr>
-          <a:xfrm>
-            <a:off x="7278624" y="2148840"/>
-            <a:ext cx="1316736" cy="365760"/>
-          </a:xfrm>
-          <a:prstGeom prst="rect">
-            <a:avLst/>
-          </a:prstGeom>
-          <a:noFill/>
-          <a:ln/>
-        </p:spPr>
-        <p:txBody>
-          <a:bodyPr wrap="square" lIns="0" tIns="0" rIns="0" bIns="0" rtlCol="0" anchor="ctr"/>
-          <a:lstStyle/>
-          <a:p>
-            <a:pPr algn="ctr" indent="0" marL="0">
-              <a:buNone/>
-            </a:pPr>
-            <a:r>
-              <a:rPr lang="en-US" sz="1600" b="1" dirty="0">
-                <a:solidFill>
-                  <a:srgbClr val="1D231F"/>
-                </a:solidFill>
-                <a:latin typeface="Cambria" pitchFamily="34" charset="0"/>
-                <a:ea typeface="Cambria" pitchFamily="34" charset="-122"/>
-                <a:cs typeface="Cambria" pitchFamily="34" charset="-120"/>
-              </a:rPr>
-              <a:t>Passport</a:t>
-            </a:r>
-            <a:endParaRPr lang="en-US" sz="1600" dirty="0"/>
-          </a:p>
-        </p:txBody>
-      </p:sp>
-      <p:sp>
-        <p:nvSpPr>
-          <p:cNvPr id="27" name="Text 25"/>
-          <p:cNvSpPr txBox="1"/>
-          <p:nvPr/>
-        </p:nvSpPr>
-        <p:spPr>
-          <a:xfrm>
-            <a:off x="7296912" y="2560320"/>
-            <a:ext cx="1280160" cy="914400"/>
-          </a:xfrm>
-          <a:prstGeom prst="rect">
-            <a:avLst/>
-          </a:prstGeom>
-          <a:noFill/>
-          <a:ln/>
-        </p:spPr>
-        <p:txBody>
-          <a:bodyPr wrap="square" lIns="0" tIns="0" rIns="0" bIns="0" rtlCol="0" anchor="ctr"/>
-          <a:lstStyle/>
-          <a:p>
-            <a:pPr algn="ctr" indent="0" marL="0">
-              <a:buNone/>
-            </a:pPr>
-            <a:r>
-              <a:rPr lang="en-US" sz="1200" dirty="0">
-                <a:solidFill>
-                  <a:srgbClr val="5D665F"/>
-                </a:solidFill>
-                <a:latin typeface="Calibri" pitchFamily="34" charset="0"/>
-                <a:ea typeface="Calibri" pitchFamily="34" charset="-122"/>
-                <a:cs typeface="Calibri" pitchFamily="34" charset="-120"/>
-              </a:rPr>
-              <a:t>QR spray record for the buyer</a:t>
-            </a:r>
-            <a:endParaRPr lang="en-US" sz="1200" dirty="0"/>
-          </a:p>
-        </p:txBody>
-      </p:sp>
-      <p:sp>
-        <p:nvSpPr>
-          <p:cNvPr id="28" name="Text 26"/>
-          <p:cNvSpPr txBox="1"/>
-          <p:nvPr/>
-        </p:nvSpPr>
-        <p:spPr>
-          <a:xfrm>
-            <a:off x="457200" y="3931920"/>
-            <a:ext cx="8229600" cy="457200"/>
-          </a:xfrm>
-          <a:prstGeom prst="rect">
-            <a:avLst/>
-          </a:prstGeom>
-          <a:noFill/>
-          <a:ln/>
-        </p:spPr>
-        <p:txBody>
-          <a:bodyPr wrap="square" lIns="0" tIns="0" rIns="0" bIns="0" rtlCol="0" anchor="ctr"/>
-          <a:lstStyle/>
-          <a:p>
-            <a:pPr algn="ctr" indent="0" marL="0">
-              <a:buNone/>
-            </a:pPr>
-            <a:r>
-              <a:rPr lang="en-US" sz="1500" b="1" dirty="0">
-                <a:solidFill>
-                  <a:srgbClr val="14532D"/>
-                </a:solidFill>
-                <a:latin typeface="Calibri" pitchFamily="34" charset="0"/>
-                <a:ea typeface="Calibri" pitchFamily="34" charset="-122"/>
-                <a:cs typeface="Calibri" pitchFamily="34" charset="-120"/>
-              </a:rPr>
-              <a:t>Three taps to a spoken verdict in Hindi, Marathi or Punjabi. Colour + icon + sound, never colour alone.</a:t>
-            </a:r>
-            <a:endParaRPr lang="en-US" sz="1500" dirty="0"/>
+              <a:t>Three taps to a spoken verdict in Hindi, Marathi, Punjabi or Telugu. Colour + icon + sound, never colour alone.</a:t>
+            </a:r>
+            <a:endParaRPr lang="en-US" sz="1300" dirty="0"/>
           </a:p>
         </p:txBody>
       </p:sp>
@@ -8673,12 +8346,12 @@
         </p:nvSpPr>
         <p:spPr>
           <a:xfrm>
-            <a:off x="457200" y="1965960"/>
-            <a:ext cx="8229600" cy="548640"/>
+            <a:off x="457200" y="1920240"/>
+            <a:ext cx="8229600" cy="658368"/>
           </a:xfrm>
           <a:prstGeom prst="roundRect">
             <a:avLst>
-              <a:gd name="adj" fmla="val 20000"/>
+              <a:gd name="adj" fmla="val 16667"/>
             </a:avLst>
           </a:prstGeom>
           <a:solidFill>
@@ -8700,7 +8373,7 @@
         </p:nvSpPr>
         <p:spPr>
           <a:xfrm>
-            <a:off x="594360" y="2057400"/>
+            <a:off x="594360" y="2011680"/>
             <a:ext cx="7955280" cy="320040"/>
           </a:xfrm>
           <a:prstGeom prst="rect">
@@ -8739,8 +8412,8 @@
         </p:nvSpPr>
         <p:spPr>
           <a:xfrm>
-            <a:off x="594360" y="2377440"/>
-            <a:ext cx="7955280" cy="91440"/>
+            <a:off x="594360" y="2331720"/>
+            <a:ext cx="7955280" cy="201168"/>
           </a:xfrm>
           <a:prstGeom prst="rect">
             <a:avLst/>
@@ -9093,12 +8766,12 @@
         </p:nvSpPr>
         <p:spPr>
           <a:xfrm>
-            <a:off x="457200" y="3886200"/>
-            <a:ext cx="8229600" cy="685800"/>
+            <a:off x="457200" y="3840480"/>
+            <a:ext cx="8229600" cy="822960"/>
           </a:xfrm>
           <a:prstGeom prst="roundRect">
             <a:avLst>
-              <a:gd name="adj" fmla="val 16000"/>
+              <a:gd name="adj" fmla="val 13333"/>
             </a:avLst>
           </a:prstGeom>
           <a:solidFill>
@@ -9120,7 +8793,7 @@
         </p:nvSpPr>
         <p:spPr>
           <a:xfrm>
-            <a:off x="594360" y="3977640"/>
+            <a:off x="594360" y="3931920"/>
             <a:ext cx="7955280" cy="320040"/>
           </a:xfrm>
           <a:prstGeom prst="rect">
@@ -9159,8 +8832,8 @@
         </p:nvSpPr>
         <p:spPr>
           <a:xfrm>
-            <a:off x="594360" y="4297680"/>
-            <a:ext cx="7955280" cy="228600"/>
+            <a:off x="594360" y="4251960"/>
+            <a:ext cx="7955280" cy="365760"/>
           </a:xfrm>
           <a:prstGeom prst="rect">
             <a:avLst/>
@@ -9297,7 +8970,7 @@
         <p:spPr>
           <a:xfrm>
             <a:off x="685800" y="1280160"/>
-            <a:ext cx="1737360" cy="868680"/>
+            <a:ext cx="1920240" cy="868680"/>
           </a:xfrm>
           <a:prstGeom prst="rect">
             <a:avLst/>
@@ -9313,7 +8986,7 @@
               <a:buNone/>
             </a:pPr>
             <a:r>
-              <a:rPr lang="en-US" sz="3600" b="1" dirty="0">
+              <a:rPr lang="en-US" sz="3000" b="1" dirty="0">
                 <a:solidFill>
                   <a:srgbClr val="1F7A3A"/>
                 </a:solidFill>
@@ -9321,9 +8994,9 @@
                 <a:ea typeface="Cambria" pitchFamily="34" charset="-122"/>
                 <a:cs typeface="Cambria" pitchFamily="34" charset="-120"/>
               </a:rPr>
-              <a:t>79</a:t>
-            </a:r>
-            <a:endParaRPr lang="en-US" sz="3600" dirty="0"/>
+              <a:t>99</a:t>
+            </a:r>
+            <a:endParaRPr lang="en-US" sz="3000" dirty="0"/>
           </a:p>
         </p:txBody>
       </p:sp>
@@ -9335,8 +9008,8 @@
         </p:nvSpPr>
         <p:spPr>
           <a:xfrm>
-            <a:off x="2423160" y="1325880"/>
-            <a:ext cx="1828800" cy="777240"/>
+            <a:off x="2651760" y="1325880"/>
+            <a:ext cx="1600200" cy="777240"/>
           </a:xfrm>
           <a:prstGeom prst="rect">
             <a:avLst/>
@@ -9352,7 +9025,7 @@
               <a:buNone/>
             </a:pPr>
             <a:r>
-              <a:rPr lang="en-US" sz="1300" dirty="0">
+              <a:rPr lang="en-US" sz="1250" dirty="0">
                 <a:solidFill>
                   <a:srgbClr val="1D231F"/>
                 </a:solidFill>
@@ -9360,9 +9033,9 @@
                 <a:ea typeface="Calibri" pitchFamily="34" charset="-122"/>
                 <a:cs typeface="Calibri" pitchFamily="34" charset="-120"/>
               </a:rPr>
-              <a:t>automated tests passing (rules, API, pipeline)</a:t>
-            </a:r>
-            <a:endParaRPr lang="en-US" sz="1300" dirty="0"/>
+              <a:t>automated tests passing, incl. photo OCR end to end</a:t>
+            </a:r>
+            <a:endParaRPr lang="en-US" sz="1250" dirty="0"/>
           </a:p>
         </p:txBody>
       </p:sp>
@@ -9402,7 +9075,7 @@
         <p:spPr>
           <a:xfrm>
             <a:off x="4892040" y="1280160"/>
-            <a:ext cx="1737360" cy="868680"/>
+            <a:ext cx="1920240" cy="868680"/>
           </a:xfrm>
           <a:prstGeom prst="rect">
             <a:avLst/>
@@ -9418,7 +9091,7 @@
               <a:buNone/>
             </a:pPr>
             <a:r>
-              <a:rPr lang="en-US" sz="3600" b="1" dirty="0">
+              <a:rPr lang="en-US" sz="3000" b="1" dirty="0">
                 <a:solidFill>
                   <a:srgbClr val="1F7A3A"/>
                 </a:solidFill>
@@ -9426,9 +9099,9 @@
                 <a:ea typeface="Cambria" pitchFamily="34" charset="-122"/>
                 <a:cs typeface="Cambria" pitchFamily="34" charset="-120"/>
               </a:rPr>
-              <a:t>30 / 30</a:t>
-            </a:r>
-            <a:endParaRPr lang="en-US" sz="3600" dirty="0"/>
+              <a:t>30/30</a:t>
+            </a:r>
+            <a:endParaRPr lang="en-US" sz="3000" dirty="0"/>
           </a:p>
         </p:txBody>
       </p:sp>
@@ -9440,8 +9113,8 @@
         </p:nvSpPr>
         <p:spPr>
           <a:xfrm>
-            <a:off x="6629400" y="1325880"/>
-            <a:ext cx="1828800" cy="777240"/>
+            <a:off x="6858000" y="1325880"/>
+            <a:ext cx="1600200" cy="777240"/>
           </a:xfrm>
           <a:prstGeom prst="rect">
             <a:avLst/>
@@ -9457,7 +9130,7 @@
               <a:buNone/>
             </a:pPr>
             <a:r>
-              <a:rPr lang="en-US" sz="1300" dirty="0">
+              <a:rPr lang="en-US" sz="1250" dirty="0">
                 <a:solidFill>
                   <a:srgbClr val="1D231F"/>
                 </a:solidFill>
@@ -9467,7 +9140,7 @@
               </a:rPr>
               <a:t>knowledge-base questions answered correctly</a:t>
             </a:r>
-            <a:endParaRPr lang="en-US" sz="1300" dirty="0"/>
+            <a:endParaRPr lang="en-US" sz="1250" dirty="0"/>
           </a:p>
         </p:txBody>
       </p:sp>
@@ -9507,7 +9180,7 @@
         <p:spPr>
           <a:xfrm>
             <a:off x="685800" y="2606040"/>
-            <a:ext cx="1737360" cy="868680"/>
+            <a:ext cx="1920240" cy="868680"/>
           </a:xfrm>
           <a:prstGeom prst="rect">
             <a:avLst/>
@@ -9523,7 +9196,7 @@
               <a:buNone/>
             </a:pPr>
             <a:r>
-              <a:rPr lang="en-US" sz="3600" b="1" dirty="0">
+              <a:rPr lang="en-US" sz="3000" b="1" dirty="0">
                 <a:solidFill>
                   <a:srgbClr val="1F7A3A"/>
                 </a:solidFill>
@@ -9531,9 +9204,9 @@
                 <a:ea typeface="Cambria" pitchFamily="34" charset="-122"/>
                 <a:cs typeface="Cambria" pitchFamily="34" charset="-120"/>
               </a:rPr>
-              <a:t>13</a:t>
-            </a:r>
-            <a:endParaRPr lang="en-US" sz="3600" dirty="0"/>
+              <a:t>R1–R13</a:t>
+            </a:r>
+            <a:endParaRPr lang="en-US" sz="3000" dirty="0"/>
           </a:p>
         </p:txBody>
       </p:sp>
@@ -9545,8 +9218,8 @@
         </p:nvSpPr>
         <p:spPr>
           <a:xfrm>
-            <a:off x="2423160" y="2651760"/>
-            <a:ext cx="1828800" cy="777240"/>
+            <a:off x="2651760" y="2651760"/>
+            <a:ext cx="1600200" cy="777240"/>
           </a:xfrm>
           <a:prstGeom prst="rect">
             <a:avLst/>
@@ -9562,7 +9235,7 @@
               <a:buNone/>
             </a:pPr>
             <a:r>
-              <a:rPr lang="en-US" sz="1300" dirty="0">
+              <a:rPr lang="en-US" sz="1250" dirty="0">
                 <a:solidFill>
                   <a:srgbClr val="1D231F"/>
                 </a:solidFill>
@@ -9570,9 +9243,9 @@
                 <a:ea typeface="Calibri" pitchFamily="34" charset="-122"/>
                 <a:cs typeface="Calibri" pitchFamily="34" charset="-120"/>
               </a:rPr>
-              <a:t>verdict rules, each citing its source</a:t>
-            </a:r>
-            <a:endParaRPr lang="en-US" sz="1300" dirty="0"/>
+              <a:t>verdict rules stored as data, each citing its source</a:t>
+            </a:r>
+            <a:endParaRPr lang="en-US" sz="1250" dirty="0"/>
           </a:p>
         </p:txBody>
       </p:sp>
@@ -9612,7 +9285,7 @@
         <p:spPr>
           <a:xfrm>
             <a:off x="4892040" y="2606040"/>
-            <a:ext cx="1737360" cy="868680"/>
+            <a:ext cx="1920240" cy="868680"/>
           </a:xfrm>
           <a:prstGeom prst="rect">
             <a:avLst/>
@@ -9628,7 +9301,7 @@
               <a:buNone/>
             </a:pPr>
             <a:r>
-              <a:rPr lang="en-US" sz="3600" b="1" dirty="0">
+              <a:rPr lang="en-US" sz="3000" b="1" dirty="0">
                 <a:solidFill>
                   <a:srgbClr val="1F7A3A"/>
                 </a:solidFill>
@@ -9636,9 +9309,9 @@
                 <a:ea typeface="Cambria" pitchFamily="34" charset="-122"/>
                 <a:cs typeface="Cambria" pitchFamily="34" charset="-120"/>
               </a:rPr>
-              <a:t>4</a:t>
-            </a:r>
-            <a:endParaRPr lang="en-US" sz="3600" dirty="0"/>
+              <a:t>5</a:t>
+            </a:r>
+            <a:endParaRPr lang="en-US" sz="3000" dirty="0"/>
           </a:p>
         </p:txBody>
       </p:sp>
@@ -9650,8 +9323,8 @@
         </p:nvSpPr>
         <p:spPr>
           <a:xfrm>
-            <a:off x="6629400" y="2651760"/>
-            <a:ext cx="1828800" cy="777240"/>
+            <a:off x="6858000" y="2651760"/>
+            <a:ext cx="1600200" cy="777240"/>
           </a:xfrm>
           <a:prstGeom prst="rect">
             <a:avLst/>
@@ -9667,7 +9340,7 @@
               <a:buNone/>
             </a:pPr>
             <a:r>
-              <a:rPr lang="en-US" sz="1300" dirty="0">
+              <a:rPr lang="en-US" sz="1250" dirty="0">
                 <a:solidFill>
                   <a:srgbClr val="1D231F"/>
                 </a:solidFill>
@@ -9675,9 +9348,9 @@
                 <a:ea typeface="Calibri" pitchFamily="34" charset="-122"/>
                 <a:cs typeface="Calibri" pitchFamily="34" charset="-120"/>
               </a:rPr>
-              <a:t>languages: English, Hindi, Marathi, Punjabi</a:t>
-            </a:r>
-            <a:endParaRPr lang="en-US" sz="1300" dirty="0"/>
+              <a:t>languages: English, Hindi, Marathi, Punjabi, Telugu</a:t>
+            </a:r>
+            <a:endParaRPr lang="en-US" sz="1250" dirty="0"/>
           </a:p>
         </p:txBody>
       </p:sp>
@@ -9714,7 +9387,7 @@
                 <a:ea typeface="Calibri" pitchFamily="34" charset="-122"/>
                 <a:cs typeface="Calibri" pitchFamily="34" charset="-120"/>
               </a:rPr>
-              <a:t>To add before the pitch: OCR + extraction accuracy on 50 real packs, and counts of products and label claims loaded from the parsed CIB&amp;RC PDFs (current label claims are sample data).</a:t>
+              <a:t>To add before the pitch: accuracy on your 50 real pack photos (run scripts/accuracy_report.py) and the counts of products and label claims loaded from the parsed CIB&amp;RC PDFs (current label claims are sample data).</a:t>
             </a:r>
             <a:endParaRPr lang="en-US" sz="1200" dirty="0"/>
           </a:p>

</xml_diff>